<commit_message>
Update presentation slides to include a visual methodology flowchart and technical commentary
Updates slides with a split-sample flowchart, technical commentary on EFA results, an improved goodness-of-fit table with thresholds, and a new slide on methodological improvements.

Replit-Commit-Author: Agent
Replit-Commit-Session-Id: d1af01ac-c843-4bff-a7a9-fedef4198273
Replit-Commit-Checkpoint-Type: full_checkpoint
Replit-Commit-Event-Id: 883313d3-189a-48c8-949e-e6ee26912389
Replit-Helium-Checkpoint-Created: true
</commit_message>
<xml_diff>
--- a/Factor_Analysis_Women_WorkEngagement_Presentation.pptx
+++ b/Factor_Analysis_Women_WorkEngagement_Presentation.pptx
@@ -30,6 +30,7 @@
     <p:sldId id="278" r:id="rId29"/>
     <p:sldId id="279" r:id="rId30"/>
     <p:sldId id="280" r:id="rId31"/>
+    <p:sldId id="281" r:id="rId32"/>
   </p:sldIdLst>
   <p:sldSz cx="9144000" cy="6858000" type="screen4x3"/>
   <p:notesSz cx="6858000" cy="9144000"/>
@@ -4099,7 +4100,73 @@
       </p:sp>
       <p:sp>
         <p:nvSpPr>
-          <p:cNvPr id="5" name="TextBox 4"/>
+          <p:cNvPr id="5" name="Rounded Rectangle 4"/>
+          <p:cNvSpPr/>
+          <p:nvPr/>
+        </p:nvSpPr>
+        <p:spPr>
+          <a:xfrm>
+            <a:off x="457200" y="5303520"/>
+            <a:ext cx="8229600" cy="1097280"/>
+          </a:xfrm>
+          <a:prstGeom prst="roundRect">
+            <a:avLst/>
+          </a:prstGeom>
+          <a:solidFill>
+            <a:srgbClr val="FFF3E0"/>
+          </a:solidFill>
+          <a:ln w="25400">
+            <a:solidFill>
+              <a:srgbClr val="E76F51"/>
+            </a:solidFill>
+          </a:ln>
+        </p:spPr>
+        <p:style>
+          <a:lnRef idx="1">
+            <a:schemeClr val="accent1"/>
+          </a:lnRef>
+          <a:fillRef idx="3">
+            <a:schemeClr val="accent1"/>
+          </a:fillRef>
+          <a:effectRef idx="2">
+            <a:schemeClr val="accent1"/>
+          </a:effectRef>
+          <a:fontRef idx="minor">
+            <a:schemeClr val="lt1"/>
+          </a:fontRef>
+        </p:style>
+        <p:txBody>
+          <a:bodyPr rtlCol="0" anchor="ctr" wrap="square" lIns="137160" rIns="137160"/>
+          <a:lstStyle/>
+          <a:p>
+            <a:pPr algn="ctr">
+              <a:defRPr sz="1100" b="1">
+                <a:solidFill>
+                  <a:srgbClr val="E76F51"/>
+                </a:solidFill>
+              </a:defRPr>
+            </a:pPr>
+            <a:r>
+              <a:t>Technical Commentary:</a:t>
+            </a:r>
+          </a:p>
+          <a:p>
+            <a:pPr>
+              <a:defRPr sz="1000">
+                <a:solidFill>
+                  <a:srgbClr val="323232"/>
+                </a:solidFill>
+              </a:defRPr>
+            </a:pPr>
+            <a:r>
+              <a:t>While EFA and MAP tests supported a 1-factor solution, Parallel Analysis suggested 4 factors. This often occurs in multivariate data with high inter-item correlations (0.52-0.85), leading to 'over-factoring' -- a known limitation of Parallel Analysis in highly correlated datasets.</a:t>
+            </a:r>
+          </a:p>
+        </p:txBody>
+      </p:sp>
+      <p:sp>
+        <p:nvSpPr>
+          <p:cNvPr id="6" name="TextBox 5"/>
           <p:cNvSpPr txBox="1"/>
           <p:nvPr/>
         </p:nvSpPr>
@@ -6139,7 +6206,7 @@
               </a:defRPr>
             </a:pPr>
             <a:r>
-              <a:t>Goodness-of-Fit: Full Table</a:t>
+              <a:t>Goodness-of-Fit: Full Table with Thresholds</a:t>
             </a:r>
           </a:p>
           <a:p>
@@ -6151,7 +6218,7 @@
               </a:defRPr>
             </a:pPr>
             <a:r>
-              <a:t>Table 5 from Willmer et al. (2019)</a:t>
+              <a:t>Table 5 | Red = Failed to Meet Acceptable Threshold</a:t>
             </a:r>
           </a:p>
         </p:txBody>
@@ -6199,33 +6266,874 @@
           </a:p>
         </p:txBody>
       </p:sp>
-      <p:pic>
-        <p:nvPicPr>
-          <p:cNvPr id="4" name="Picture 3" descr="gof_table.png"/>
-          <p:cNvPicPr>
-            <a:picLocks noChangeAspect="1"/>
-          </p:cNvPicPr>
+      <p:graphicFrame>
+        <p:nvGraphicFramePr>
+          <p:cNvPr id="4" name="Table 3"/>
+          <p:cNvGraphicFramePr>
+            <a:graphicFrameLocks noGrp="1"/>
+          </p:cNvGraphicFramePr>
           <p:nvPr/>
-        </p:nvPicPr>
-        <p:blipFill>
-          <a:blip r:embed="rId2"/>
-          <a:stretch>
-            <a:fillRect/>
-          </a:stretch>
-        </p:blipFill>
+        </p:nvGraphicFramePr>
+        <p:xfrm>
+          <a:off x="274320" y="1371600"/>
+          <a:ext cx="8595360" cy="4389120"/>
+        </p:xfrm>
+        <a:graphic>
+          <a:graphicData uri="http://schemas.openxmlformats.org/drawingml/2006/table">
+            <a:tbl>
+              <a:tblPr firstRow="1" bandRow="1">
+                <a:tableStyleId>{5C22544A-7EE6-4342-B048-85BDC9FD1C3A}</a:tableStyleId>
+              </a:tblPr>
+              <a:tblGrid>
+                <a:gridCol w="1645920"/>
+                <a:gridCol w="1463040"/>
+                <a:gridCol w="1463040"/>
+                <a:gridCol w="1463040"/>
+                <a:gridCol w="2560320"/>
+              </a:tblGrid>
+              <a:tr h="487680">
+                <a:tc>
+                  <a:txBody>
+                    <a:bodyPr/>
+                    <a:lstStyle/>
+                    <a:p>
+                      <a:pPr algn="ctr">
+                        <a:defRPr sz="1000" b="1">
+                          <a:solidFill>
+                            <a:srgbClr val="FFFFFF"/>
+                          </a:solidFill>
+                        </a:defRPr>
+                      </a:pPr>
+                      <a:r>
+                        <a:t>Fit Statistic</a:t>
+                      </a:r>
+                    </a:p>
+                  </a:txBody>
+                  <a:tcPr anchor="ctr">
+                    <a:solidFill>
+                      <a:srgbClr val="6B2D7B"/>
+                    </a:solidFill>
+                  </a:tcPr>
+                </a:tc>
+                <a:tc>
+                  <a:txBody>
+                    <a:bodyPr/>
+                    <a:lstStyle/>
+                    <a:p>
+                      <a:pPr algn="ctr">
+                        <a:defRPr sz="1000" b="1">
+                          <a:solidFill>
+                            <a:srgbClr val="FFFFFF"/>
+                          </a:solidFill>
+                        </a:defRPr>
+                      </a:pPr>
+                      <a:r>
+                        <a:t>One-Factor</a:t>
+                      </a:r>
+                    </a:p>
+                  </a:txBody>
+                  <a:tcPr anchor="ctr">
+                    <a:solidFill>
+                      <a:srgbClr val="6B2D7B"/>
+                    </a:solidFill>
+                  </a:tcPr>
+                </a:tc>
+                <a:tc>
+                  <a:txBody>
+                    <a:bodyPr/>
+                    <a:lstStyle/>
+                    <a:p>
+                      <a:pPr algn="ctr">
+                        <a:defRPr sz="1000" b="1">
+                          <a:solidFill>
+                            <a:srgbClr val="FFFFFF"/>
+                          </a:solidFill>
+                        </a:defRPr>
+                      </a:pPr>
+                      <a:r>
+                        <a:t>Two-Factor</a:t>
+                      </a:r>
+                    </a:p>
+                  </a:txBody>
+                  <a:tcPr anchor="ctr">
+                    <a:solidFill>
+                      <a:srgbClr val="6B2D7B"/>
+                    </a:solidFill>
+                  </a:tcPr>
+                </a:tc>
+                <a:tc>
+                  <a:txBody>
+                    <a:bodyPr/>
+                    <a:lstStyle/>
+                    <a:p>
+                      <a:pPr algn="ctr">
+                        <a:defRPr sz="1000" b="1">
+                          <a:solidFill>
+                            <a:srgbClr val="FFFFFF"/>
+                          </a:solidFill>
+                        </a:defRPr>
+                      </a:pPr>
+                      <a:r>
+                        <a:t>Three-Factor</a:t>
+                      </a:r>
+                    </a:p>
+                  </a:txBody>
+                  <a:tcPr anchor="ctr">
+                    <a:solidFill>
+                      <a:srgbClr val="6B2D7B"/>
+                    </a:solidFill>
+                  </a:tcPr>
+                </a:tc>
+                <a:tc>
+                  <a:txBody>
+                    <a:bodyPr/>
+                    <a:lstStyle/>
+                    <a:p>
+                      <a:pPr algn="ctr">
+                        <a:defRPr sz="1000" b="1">
+                          <a:solidFill>
+                            <a:srgbClr val="FFFFFF"/>
+                          </a:solidFill>
+                        </a:defRPr>
+                      </a:pPr>
+                      <a:r>
+                        <a:t>Good Fit Threshold</a:t>
+                      </a:r>
+                    </a:p>
+                  </a:txBody>
+                  <a:tcPr anchor="ctr">
+                    <a:solidFill>
+                      <a:srgbClr val="6B2D7B"/>
+                    </a:solidFill>
+                  </a:tcPr>
+                </a:tc>
+              </a:tr>
+              <a:tr h="487680">
+                <a:tc>
+                  <a:txBody>
+                    <a:bodyPr/>
+                    <a:lstStyle/>
+                    <a:p>
+                      <a:pPr algn="ctr">
+                        <a:defRPr sz="1000"/>
+                      </a:pPr>
+                      <a:r>
+                        <a:t>Chi2 (df)</a:t>
+                      </a:r>
+                    </a:p>
+                  </a:txBody>
+                  <a:tcPr anchor="ctr"/>
+                </a:tc>
+                <a:tc>
+                  <a:txBody>
+                    <a:bodyPr/>
+                    <a:lstStyle/>
+                    <a:p>
+                      <a:pPr algn="ctr">
+                        <a:defRPr sz="1000"/>
+                      </a:pPr>
+                      <a:r>
+                        <a:t>633.90 (27)</a:t>
+                      </a:r>
+                    </a:p>
+                  </a:txBody>
+                  <a:tcPr anchor="ctr"/>
+                </a:tc>
+                <a:tc>
+                  <a:txBody>
+                    <a:bodyPr/>
+                    <a:lstStyle/>
+                    <a:p>
+                      <a:pPr algn="ctr">
+                        <a:defRPr sz="1000"/>
+                      </a:pPr>
+                      <a:r>
+                        <a:t>354.49 (26)</a:t>
+                      </a:r>
+                    </a:p>
+                  </a:txBody>
+                  <a:tcPr anchor="ctr"/>
+                </a:tc>
+                <a:tc>
+                  <a:txBody>
+                    <a:bodyPr/>
+                    <a:lstStyle/>
+                    <a:p>
+                      <a:pPr algn="ctr">
+                        <a:defRPr sz="1000"/>
+                      </a:pPr>
+                      <a:r>
+                        <a:t>247.76 (24)</a:t>
+                      </a:r>
+                    </a:p>
+                  </a:txBody>
+                  <a:tcPr anchor="ctr"/>
+                </a:tc>
+                <a:tc>
+                  <a:txBody>
+                    <a:bodyPr/>
+                    <a:lstStyle/>
+                    <a:p>
+                      <a:pPr algn="ctr">
+                        <a:defRPr sz="1000"/>
+                      </a:pPr>
+                      <a:r>
+                        <a:t>Non-significant</a:t>
+                      </a:r>
+                    </a:p>
+                  </a:txBody>
+                  <a:tcPr anchor="ctr">
+                    <a:solidFill>
+                      <a:srgbClr val="FFF3E0"/>
+                    </a:solidFill>
+                  </a:tcPr>
+                </a:tc>
+              </a:tr>
+              <a:tr h="487680">
+                <a:tc>
+                  <a:txBody>
+                    <a:bodyPr/>
+                    <a:lstStyle/>
+                    <a:p>
+                      <a:pPr algn="ctr">
+                        <a:defRPr sz="1000"/>
+                      </a:pPr>
+                      <a:r>
+                        <a:t>RMSEA</a:t>
+                      </a:r>
+                    </a:p>
+                  </a:txBody>
+                  <a:tcPr anchor="ctr"/>
+                </a:tc>
+                <a:tc>
+                  <a:txBody>
+                    <a:bodyPr/>
+                    <a:lstStyle/>
+                    <a:p>
+                      <a:pPr algn="ctr">
+                        <a:defRPr sz="1000" b="1">
+                          <a:solidFill>
+                            <a:srgbClr val="C0392B"/>
+                          </a:solidFill>
+                        </a:defRPr>
+                      </a:pPr>
+                      <a:r>
+                        <a:t>0.181</a:t>
+                      </a:r>
+                    </a:p>
+                  </a:txBody>
+                  <a:tcPr anchor="ctr"/>
+                </a:tc>
+                <a:tc>
+                  <a:txBody>
+                    <a:bodyPr/>
+                    <a:lstStyle/>
+                    <a:p>
+                      <a:pPr algn="ctr">
+                        <a:defRPr sz="1000" b="1">
+                          <a:solidFill>
+                            <a:srgbClr val="C0392B"/>
+                          </a:solidFill>
+                        </a:defRPr>
+                      </a:pPr>
+                      <a:r>
+                        <a:t>0.192</a:t>
+                      </a:r>
+                    </a:p>
+                  </a:txBody>
+                  <a:tcPr anchor="ctr"/>
+                </a:tc>
+                <a:tc>
+                  <a:txBody>
+                    <a:bodyPr/>
+                    <a:lstStyle/>
+                    <a:p>
+                      <a:pPr algn="ctr">
+                        <a:defRPr sz="1000" b="1">
+                          <a:solidFill>
+                            <a:srgbClr val="C0392B"/>
+                          </a:solidFill>
+                        </a:defRPr>
+                      </a:pPr>
+                      <a:r>
+                        <a:t>0.167</a:t>
+                      </a:r>
+                    </a:p>
+                  </a:txBody>
+                  <a:tcPr anchor="ctr"/>
+                </a:tc>
+                <a:tc>
+                  <a:txBody>
+                    <a:bodyPr/>
+                    <a:lstStyle/>
+                    <a:p>
+                      <a:pPr algn="ctr">
+                        <a:defRPr sz="1000"/>
+                      </a:pPr>
+                      <a:r>
+                        <a:t>&lt; 0.05 (pref.) / &lt; 0.08</a:t>
+                      </a:r>
+                    </a:p>
+                  </a:txBody>
+                  <a:tcPr anchor="ctr">
+                    <a:solidFill>
+                      <a:srgbClr val="FFF3E0"/>
+                    </a:solidFill>
+                  </a:tcPr>
+                </a:tc>
+              </a:tr>
+              <a:tr h="487680">
+                <a:tc>
+                  <a:txBody>
+                    <a:bodyPr/>
+                    <a:lstStyle/>
+                    <a:p>
+                      <a:pPr algn="ctr">
+                        <a:defRPr sz="1000"/>
+                      </a:pPr>
+                      <a:r>
+                        <a:t>RMSEA 90% CI</a:t>
+                      </a:r>
+                    </a:p>
+                  </a:txBody>
+                  <a:tcPr anchor="ctr"/>
+                </a:tc>
+                <a:tc>
+                  <a:txBody>
+                    <a:bodyPr/>
+                    <a:lstStyle/>
+                    <a:p>
+                      <a:pPr algn="ctr">
+                        <a:defRPr sz="1000"/>
+                      </a:pPr>
+                      <a:r>
+                        <a:t>0.169-0.194</a:t>
+                      </a:r>
+                    </a:p>
+                  </a:txBody>
+                  <a:tcPr anchor="ctr"/>
+                </a:tc>
+                <a:tc>
+                  <a:txBody>
+                    <a:bodyPr/>
+                    <a:lstStyle/>
+                    <a:p>
+                      <a:pPr algn="ctr">
+                        <a:defRPr sz="1000"/>
+                      </a:pPr>
+                      <a:r>
+                        <a:t>0.175-0.192</a:t>
+                      </a:r>
+                    </a:p>
+                  </a:txBody>
+                  <a:tcPr anchor="ctr"/>
+                </a:tc>
+                <a:tc>
+                  <a:txBody>
+                    <a:bodyPr/>
+                    <a:lstStyle/>
+                    <a:p>
+                      <a:pPr algn="ctr">
+                        <a:defRPr sz="1000"/>
+                      </a:pPr>
+                      <a:r>
+                        <a:t>0.154-0.180</a:t>
+                      </a:r>
+                    </a:p>
+                  </a:txBody>
+                  <a:tcPr anchor="ctr"/>
+                </a:tc>
+                <a:tc>
+                  <a:txBody>
+                    <a:bodyPr/>
+                    <a:lstStyle/>
+                    <a:p>
+                      <a:pPr algn="ctr">
+                        <a:defRPr sz="1000"/>
+                      </a:pPr>
+                      <a:r>
+                        <a:t>--</a:t>
+                      </a:r>
+                    </a:p>
+                  </a:txBody>
+                  <a:tcPr anchor="ctr">
+                    <a:solidFill>
+                      <a:srgbClr val="FFF3E0"/>
+                    </a:solidFill>
+                  </a:tcPr>
+                </a:tc>
+              </a:tr>
+              <a:tr h="487680">
+                <a:tc>
+                  <a:txBody>
+                    <a:bodyPr/>
+                    <a:lstStyle/>
+                    <a:p>
+                      <a:pPr algn="ctr">
+                        <a:defRPr sz="1000"/>
+                      </a:pPr>
+                      <a:r>
+                        <a:t>AIC</a:t>
+                      </a:r>
+                    </a:p>
+                  </a:txBody>
+                  <a:tcPr anchor="ctr"/>
+                </a:tc>
+                <a:tc>
+                  <a:txBody>
+                    <a:bodyPr/>
+                    <a:lstStyle/>
+                    <a:p>
+                      <a:pPr algn="ctr">
+                        <a:defRPr sz="1000"/>
+                      </a:pPr>
+                      <a:r>
+                        <a:t>16221.47</a:t>
+                      </a:r>
+                    </a:p>
+                  </a:txBody>
+                  <a:tcPr anchor="ctr"/>
+                </a:tc>
+                <a:tc>
+                  <a:txBody>
+                    <a:bodyPr/>
+                    <a:lstStyle/>
+                    <a:p>
+                      <a:pPr algn="ctr">
+                        <a:defRPr sz="1000"/>
+                      </a:pPr>
+                      <a:r>
+                        <a:t>8246.29</a:t>
+                      </a:r>
+                    </a:p>
+                  </a:txBody>
+                  <a:tcPr anchor="ctr"/>
+                </a:tc>
+                <a:tc>
+                  <a:txBody>
+                    <a:bodyPr/>
+                    <a:lstStyle/>
+                    <a:p>
+                      <a:pPr algn="ctr">
+                        <a:defRPr sz="1000"/>
+                      </a:pPr>
+                      <a:r>
+                        <a:t>8143.56</a:t>
+                      </a:r>
+                    </a:p>
+                  </a:txBody>
+                  <a:tcPr anchor="ctr"/>
+                </a:tc>
+                <a:tc>
+                  <a:txBody>
+                    <a:bodyPr/>
+                    <a:lstStyle/>
+                    <a:p>
+                      <a:pPr algn="ctr">
+                        <a:defRPr sz="1000"/>
+                      </a:pPr>
+                      <a:r>
+                        <a:t>Lower = better</a:t>
+                      </a:r>
+                    </a:p>
+                  </a:txBody>
+                  <a:tcPr anchor="ctr">
+                    <a:solidFill>
+                      <a:srgbClr val="FFF3E0"/>
+                    </a:solidFill>
+                  </a:tcPr>
+                </a:tc>
+              </a:tr>
+              <a:tr h="487680">
+                <a:tc>
+                  <a:txBody>
+                    <a:bodyPr/>
+                    <a:lstStyle/>
+                    <a:p>
+                      <a:pPr algn="ctr">
+                        <a:defRPr sz="1000"/>
+                      </a:pPr>
+                      <a:r>
+                        <a:t>BIC</a:t>
+                      </a:r>
+                    </a:p>
+                  </a:txBody>
+                  <a:tcPr anchor="ctr"/>
+                </a:tc>
+                <a:tc>
+                  <a:txBody>
+                    <a:bodyPr/>
+                    <a:lstStyle/>
+                    <a:p>
+                      <a:pPr algn="ctr">
+                        <a:defRPr sz="1000"/>
+                      </a:pPr>
+                      <a:r>
+                        <a:t>16343.70</a:t>
+                      </a:r>
+                    </a:p>
+                  </a:txBody>
+                  <a:tcPr anchor="ctr"/>
+                </a:tc>
+                <a:tc>
+                  <a:txBody>
+                    <a:bodyPr/>
+                    <a:lstStyle/>
+                    <a:p>
+                      <a:pPr algn="ctr">
+                        <a:defRPr sz="1000"/>
+                      </a:pPr>
+                      <a:r>
+                        <a:t>8353.66</a:t>
+                      </a:r>
+                    </a:p>
+                  </a:txBody>
+                  <a:tcPr anchor="ctr"/>
+                </a:tc>
+                <a:tc>
+                  <a:txBody>
+                    <a:bodyPr/>
+                    <a:lstStyle/>
+                    <a:p>
+                      <a:pPr algn="ctr">
+                        <a:defRPr sz="1000"/>
+                      </a:pPr>
+                      <a:r>
+                        <a:t>8258.60</a:t>
+                      </a:r>
+                    </a:p>
+                  </a:txBody>
+                  <a:tcPr anchor="ctr"/>
+                </a:tc>
+                <a:tc>
+                  <a:txBody>
+                    <a:bodyPr/>
+                    <a:lstStyle/>
+                    <a:p>
+                      <a:pPr algn="ctr">
+                        <a:defRPr sz="1000"/>
+                      </a:pPr>
+                      <a:r>
+                        <a:t>Lower = better</a:t>
+                      </a:r>
+                    </a:p>
+                  </a:txBody>
+                  <a:tcPr anchor="ctr">
+                    <a:solidFill>
+                      <a:srgbClr val="FFF3E0"/>
+                    </a:solidFill>
+                  </a:tcPr>
+                </a:tc>
+              </a:tr>
+              <a:tr h="487680">
+                <a:tc>
+                  <a:txBody>
+                    <a:bodyPr/>
+                    <a:lstStyle/>
+                    <a:p>
+                      <a:pPr algn="ctr">
+                        <a:defRPr sz="1000"/>
+                      </a:pPr>
+                      <a:r>
+                        <a:t>CFI</a:t>
+                      </a:r>
+                    </a:p>
+                  </a:txBody>
+                  <a:tcPr anchor="ctr"/>
+                </a:tc>
+                <a:tc>
+                  <a:txBody>
+                    <a:bodyPr/>
+                    <a:lstStyle/>
+                    <a:p>
+                      <a:pPr algn="ctr">
+                        <a:defRPr sz="1000" b="1">
+                          <a:solidFill>
+                            <a:srgbClr val="C0392B"/>
+                          </a:solidFill>
+                        </a:defRPr>
+                      </a:pPr>
+                      <a:r>
+                        <a:t>0.895</a:t>
+                      </a:r>
+                    </a:p>
+                  </a:txBody>
+                  <a:tcPr anchor="ctr"/>
+                </a:tc>
+                <a:tc>
+                  <a:txBody>
+                    <a:bodyPr/>
+                    <a:lstStyle/>
+                    <a:p>
+                      <a:pPr algn="ctr">
+                        <a:defRPr sz="1000" b="1">
+                          <a:solidFill>
+                            <a:srgbClr val="C0392B"/>
+                          </a:solidFill>
+                        </a:defRPr>
+                      </a:pPr>
+                      <a:r>
+                        <a:t>0.882</a:t>
+                      </a:r>
+                    </a:p>
+                  </a:txBody>
+                  <a:tcPr anchor="ctr"/>
+                </a:tc>
+                <a:tc>
+                  <a:txBody>
+                    <a:bodyPr/>
+                    <a:lstStyle/>
+                    <a:p>
+                      <a:pPr algn="ctr">
+                        <a:defRPr sz="1000" b="1">
+                          <a:solidFill>
+                            <a:srgbClr val="C0392B"/>
+                          </a:solidFill>
+                        </a:defRPr>
+                      </a:pPr>
+                      <a:r>
+                        <a:t>0.920</a:t>
+                      </a:r>
+                    </a:p>
+                  </a:txBody>
+                  <a:tcPr anchor="ctr"/>
+                </a:tc>
+                <a:tc>
+                  <a:txBody>
+                    <a:bodyPr/>
+                    <a:lstStyle/>
+                    <a:p>
+                      <a:pPr algn="ctr">
+                        <a:defRPr sz="1000"/>
+                      </a:pPr>
+                      <a:r>
+                        <a:t>&gt; 0.95</a:t>
+                      </a:r>
+                    </a:p>
+                  </a:txBody>
+                  <a:tcPr anchor="ctr">
+                    <a:solidFill>
+                      <a:srgbClr val="FFF3E0"/>
+                    </a:solidFill>
+                  </a:tcPr>
+                </a:tc>
+              </a:tr>
+              <a:tr h="487680">
+                <a:tc>
+                  <a:txBody>
+                    <a:bodyPr/>
+                    <a:lstStyle/>
+                    <a:p>
+                      <a:pPr algn="ctr">
+                        <a:defRPr sz="1000"/>
+                      </a:pPr>
+                      <a:r>
+                        <a:t>TLI</a:t>
+                      </a:r>
+                    </a:p>
+                  </a:txBody>
+                  <a:tcPr anchor="ctr"/>
+                </a:tc>
+                <a:tc>
+                  <a:txBody>
+                    <a:bodyPr/>
+                    <a:lstStyle/>
+                    <a:p>
+                      <a:pPr algn="ctr">
+                        <a:defRPr sz="1000" b="1">
+                          <a:solidFill>
+                            <a:srgbClr val="C0392B"/>
+                          </a:solidFill>
+                        </a:defRPr>
+                      </a:pPr>
+                      <a:r>
+                        <a:t>0.860</a:t>
+                      </a:r>
+                    </a:p>
+                  </a:txBody>
+                  <a:tcPr anchor="ctr"/>
+                </a:tc>
+                <a:tc>
+                  <a:txBody>
+                    <a:bodyPr/>
+                    <a:lstStyle/>
+                    <a:p>
+                      <a:pPr algn="ctr">
+                        <a:defRPr sz="1000" b="1">
+                          <a:solidFill>
+                            <a:srgbClr val="C0392B"/>
+                          </a:solidFill>
+                        </a:defRPr>
+                      </a:pPr>
+                      <a:r>
+                        <a:t>0.837</a:t>
+                      </a:r>
+                    </a:p>
+                  </a:txBody>
+                  <a:tcPr anchor="ctr"/>
+                </a:tc>
+                <a:tc>
+                  <a:txBody>
+                    <a:bodyPr/>
+                    <a:lstStyle/>
+                    <a:p>
+                      <a:pPr algn="ctr">
+                        <a:defRPr sz="1000" b="1">
+                          <a:solidFill>
+                            <a:srgbClr val="C0392B"/>
+                          </a:solidFill>
+                        </a:defRPr>
+                      </a:pPr>
+                      <a:r>
+                        <a:t>0.880</a:t>
+                      </a:r>
+                    </a:p>
+                  </a:txBody>
+                  <a:tcPr anchor="ctr"/>
+                </a:tc>
+                <a:tc>
+                  <a:txBody>
+                    <a:bodyPr/>
+                    <a:lstStyle/>
+                    <a:p>
+                      <a:pPr algn="ctr">
+                        <a:defRPr sz="1000"/>
+                      </a:pPr>
+                      <a:r>
+                        <a:t>&gt; 0.95</a:t>
+                      </a:r>
+                    </a:p>
+                  </a:txBody>
+                  <a:tcPr anchor="ctr">
+                    <a:solidFill>
+                      <a:srgbClr val="FFF3E0"/>
+                    </a:solidFill>
+                  </a:tcPr>
+                </a:tc>
+              </a:tr>
+              <a:tr h="487680">
+                <a:tc>
+                  <a:txBody>
+                    <a:bodyPr/>
+                    <a:lstStyle/>
+                    <a:p>
+                      <a:pPr algn="ctr">
+                        <a:defRPr sz="1000"/>
+                      </a:pPr>
+                      <a:r>
+                        <a:t>SRMR</a:t>
+                      </a:r>
+                    </a:p>
+                  </a:txBody>
+                  <a:tcPr anchor="ctr"/>
+                </a:tc>
+                <a:tc>
+                  <a:txBody>
+                    <a:bodyPr/>
+                    <a:lstStyle/>
+                    <a:p>
+                      <a:pPr algn="ctr">
+                        <a:defRPr sz="1000"/>
+                      </a:pPr>
+                      <a:r>
+                        <a:t>0.046</a:t>
+                      </a:r>
+                    </a:p>
+                  </a:txBody>
+                  <a:tcPr anchor="ctr"/>
+                </a:tc>
+                <a:tc>
+                  <a:txBody>
+                    <a:bodyPr/>
+                    <a:lstStyle/>
+                    <a:p>
+                      <a:pPr algn="ctr">
+                        <a:defRPr sz="1000"/>
+                      </a:pPr>
+                      <a:r>
+                        <a:t>0.049</a:t>
+                      </a:r>
+                    </a:p>
+                  </a:txBody>
+                  <a:tcPr anchor="ctr"/>
+                </a:tc>
+                <a:tc>
+                  <a:txBody>
+                    <a:bodyPr/>
+                    <a:lstStyle/>
+                    <a:p>
+                      <a:pPr algn="ctr">
+                        <a:defRPr sz="1000"/>
+                      </a:pPr>
+                      <a:r>
+                        <a:t>0.065</a:t>
+                      </a:r>
+                    </a:p>
+                  </a:txBody>
+                  <a:tcPr anchor="ctr"/>
+                </a:tc>
+                <a:tc>
+                  <a:txBody>
+                    <a:bodyPr/>
+                    <a:lstStyle/>
+                    <a:p>
+                      <a:pPr algn="ctr">
+                        <a:defRPr sz="1000"/>
+                      </a:pPr>
+                      <a:r>
+                        <a:t>&lt; 0.08</a:t>
+                      </a:r>
+                    </a:p>
+                  </a:txBody>
+                  <a:tcPr anchor="ctr">
+                    <a:solidFill>
+                      <a:srgbClr val="FFF3E0"/>
+                    </a:solidFill>
+                  </a:tcPr>
+                </a:tc>
+              </a:tr>
+            </a:tbl>
+          </a:graphicData>
+        </a:graphic>
+      </p:graphicFrame>
+      <p:sp>
+        <p:nvSpPr>
+          <p:cNvPr id="5" name="TextBox 4"/>
+          <p:cNvSpPr txBox="1"/>
+          <p:nvPr/>
+        </p:nvSpPr>
         <p:spPr>
           <a:xfrm>
-            <a:off x="182880" y="1188720"/>
-            <a:ext cx="8778240" cy="5303520"/>
+            <a:off x="274320" y="5852160"/>
+            <a:ext cx="8595360" cy="457200"/>
           </a:xfrm>
           <a:prstGeom prst="rect">
             <a:avLst/>
           </a:prstGeom>
+          <a:noFill/>
         </p:spPr>
-      </p:pic>
-      <p:sp>
-        <p:nvSpPr>
-          <p:cNvPr id="5" name="TextBox 4"/>
+        <p:txBody>
+          <a:bodyPr wrap="square">
+            <a:spAutoFit/>
+          </a:bodyPr>
+          <a:lstStyle/>
+          <a:p>
+            <a:pPr algn="ctr">
+              <a:defRPr sz="1000" b="1">
+                <a:solidFill>
+                  <a:srgbClr val="C0392B"/>
+                </a:solidFill>
+              </a:defRPr>
+            </a:pPr>
+            <a:r>
+              <a:t>Red values = Failed to meet acceptable fit thresholds. Only SRMR met the &lt; 0.08 criterion for all models.</a:t>
+            </a:r>
+          </a:p>
+        </p:txBody>
+      </p:sp>
+      <p:sp>
+        <p:nvSpPr>
+          <p:cNvPr id="6" name="TextBox 5"/>
           <p:cNvSpPr txBox="1"/>
           <p:nvPr/>
         </p:nvSpPr>
@@ -7994,7 +8902,19 @@
               </a:defRPr>
             </a:pPr>
             <a:r>
-              <a:t>Conclusion</a:t>
+              <a:t>Technical Improvements to the UWES-9 Framework</a:t>
+            </a:r>
+          </a:p>
+          <a:p>
+            <a:pPr algn="l">
+              <a:defRPr sz="1300">
+                <a:solidFill>
+                  <a:srgbClr val="E9C46A"/>
+                </a:solidFill>
+              </a:defRPr>
+            </a:pPr>
+            <a:r>
+              <a:t>Proposed Methodological Enhancements</a:t>
             </a:r>
           </a:p>
         </p:txBody>
@@ -8044,27 +8964,46 @@
       </p:sp>
       <p:sp>
         <p:nvSpPr>
-          <p:cNvPr id="4" name="TextBox 3"/>
-          <p:cNvSpPr txBox="1"/>
+          <p:cNvPr id="4" name="Rounded Rectangle 3"/>
+          <p:cNvSpPr/>
           <p:nvPr/>
         </p:nvSpPr>
         <p:spPr>
           <a:xfrm>
-            <a:off x="457200" y="1371600"/>
-            <a:ext cx="8229600" cy="5029200"/>
+            <a:off x="274320" y="1371600"/>
+            <a:ext cx="8595360" cy="2286000"/>
           </a:xfrm>
-          <a:prstGeom prst="rect">
+          <a:prstGeom prst="roundRect">
             <a:avLst/>
           </a:prstGeom>
-          <a:noFill/>
+          <a:solidFill>
+            <a:srgbClr val="FFFFFF"/>
+          </a:solidFill>
+          <a:ln w="31750">
+            <a:solidFill>
+              <a:srgbClr val="6B2D7B"/>
+            </a:solidFill>
+          </a:ln>
         </p:spPr>
-        <p:txBody>
-          <a:bodyPr wrap="square">
-            <a:spAutoFit/>
-          </a:bodyPr>
-          <a:lstStyle/>
-          <a:p>
-            <a:pPr>
+        <p:style>
+          <a:lnRef idx="1">
+            <a:schemeClr val="accent1"/>
+          </a:lnRef>
+          <a:fillRef idx="3">
+            <a:schemeClr val="accent1"/>
+          </a:fillRef>
+          <a:effectRef idx="2">
+            <a:schemeClr val="accent1"/>
+          </a:effectRef>
+          <a:fontRef idx="minor">
+            <a:schemeClr val="lt1"/>
+          </a:fontRef>
+        </p:style>
+        <p:txBody>
+          <a:bodyPr rtlCol="0" anchor="ctr" wrap="square" lIns="182880" rIns="182880"/>
+          <a:lstStyle/>
+          <a:p>
+            <a:pPr algn="ctr">
               <a:defRPr sz="1500" b="1">
                 <a:solidFill>
                   <a:srgbClr val="6B2D7B"/>
@@ -8072,74 +9011,122 @@
               </a:defRPr>
             </a:pPr>
             <a:r>
-              <a:t>Study Summary:</a:t>
-            </a:r>
-          </a:p>
-          <a:p>
-            <a:pPr>
-              <a:defRPr sz="600"/>
-            </a:pPr>
-          </a:p>
-          <a:p>
-            <a:pPr>
-              <a:defRPr sz="1200">
+              <a:t>Bifactor Modeling</a:t>
+            </a:r>
+          </a:p>
+          <a:p>
+            <a:pPr>
+              <a:defRPr sz="1100">
                 <a:solidFill>
                   <a:srgbClr val="323232"/>
                 </a:solidFill>
               </a:defRPr>
             </a:pPr>
             <a:r>
-              <a:t>- EFA on n = 341 women: One-factor solution best fits the data</a:t>
-            </a:r>
-          </a:p>
-          <a:p>
-            <a:pPr>
-              <a:defRPr sz="1200">
+              <a:t>Since the three subscales (Vigor, Dedication, Absorption) are highly correlated (0.79-0.84), a Bifactor Model would allow for:</a:t>
+            </a:r>
+          </a:p>
+          <a:p>
+            <a:pPr>
+              <a:defRPr sz="400">
                 <a:solidFill>
                   <a:srgbClr val="323232"/>
                 </a:solidFill>
               </a:defRPr>
             </a:pPr>
-            <a:r>
-              <a:t>  (KMO = 0.922, &gt; 70% variance explained, all loadings 0.65-0.93)</a:t>
-            </a:r>
-          </a:p>
-          <a:p>
-            <a:pPr>
-              <a:defRPr sz="600"/>
-            </a:pPr>
-          </a:p>
-          <a:p>
-            <a:pPr>
-              <a:defRPr sz="1200">
+          </a:p>
+          <a:p>
+            <a:pPr>
+              <a:defRPr sz="1100">
                 <a:solidFill>
                   <a:srgbClr val="323232"/>
                 </a:solidFill>
               </a:defRPr>
             </a:pPr>
             <a:r>
-              <a:t>- CFA on n = 342 women: Could NOT confirm any model (1-, 2-, or 3-factor)</a:t>
-            </a:r>
-          </a:p>
-          <a:p>
-            <a:pPr>
-              <a:defRPr sz="1200">
+              <a:t>- A general 'Engagement' factor accounting for shared variance across all 9 items</a:t>
+            </a:r>
+          </a:p>
+          <a:p>
+            <a:pPr>
+              <a:defRPr sz="1100">
                 <a:solidFill>
                   <a:srgbClr val="323232"/>
                 </a:solidFill>
               </a:defRPr>
             </a:pPr>
             <a:r>
-              <a:t>  (RMSEA never below 0.167, CFI/TLI below 0.95 for all models)</a:t>
-            </a:r>
-          </a:p>
-          <a:p>
-            <a:pPr>
-              <a:defRPr sz="600"/>
-            </a:pPr>
-          </a:p>
-          <a:p>
-            <a:pPr>
+              <a:t>- Specific sub-factors capturing unique variance of each subscale</a:t>
+            </a:r>
+          </a:p>
+          <a:p>
+            <a:pPr>
+              <a:defRPr sz="1100">
+                <a:solidFill>
+                  <a:srgbClr val="323232"/>
+                </a:solidFill>
+              </a:defRPr>
+            </a:pPr>
+            <a:r>
+              <a:t>- Better separation of general vs. specific engagement components</a:t>
+            </a:r>
+          </a:p>
+          <a:p>
+            <a:pPr>
+              <a:defRPr sz="1100">
+                <a:solidFill>
+                  <a:srgbClr val="323232"/>
+                </a:solidFill>
+              </a:defRPr>
+            </a:pPr>
+            <a:r>
+              <a:t>- This addresses the core problem: are the subscales truly distinct?</a:t>
+            </a:r>
+          </a:p>
+        </p:txBody>
+      </p:sp>
+      <p:sp>
+        <p:nvSpPr>
+          <p:cNvPr id="5" name="Rounded Rectangle 4"/>
+          <p:cNvSpPr/>
+          <p:nvPr/>
+        </p:nvSpPr>
+        <p:spPr>
+          <a:xfrm>
+            <a:off x="274320" y="3931920"/>
+            <a:ext cx="8595360" cy="2286000"/>
+          </a:xfrm>
+          <a:prstGeom prst="roundRect">
+            <a:avLst/>
+          </a:prstGeom>
+          <a:solidFill>
+            <a:srgbClr val="FFFFFF"/>
+          </a:solidFill>
+          <a:ln w="31750">
+            <a:solidFill>
+              <a:srgbClr val="2A9D8F"/>
+            </a:solidFill>
+          </a:ln>
+        </p:spPr>
+        <p:style>
+          <a:lnRef idx="1">
+            <a:schemeClr val="accent1"/>
+          </a:lnRef>
+          <a:fillRef idx="3">
+            <a:schemeClr val="accent1"/>
+          </a:fillRef>
+          <a:effectRef idx="2">
+            <a:schemeClr val="accent1"/>
+          </a:effectRef>
+          <a:fontRef idx="minor">
+            <a:schemeClr val="lt1"/>
+          </a:fontRef>
+        </p:style>
+        <p:txBody>
+          <a:bodyPr rtlCol="0" anchor="ctr" wrap="square" lIns="182880" rIns="182880"/>
+          <a:lstStyle/>
+          <a:p>
+            <a:pPr algn="ctr">
               <a:defRPr sz="1500" b="1">
                 <a:solidFill>
                   <a:srgbClr val="2A9D8F"/>
@@ -8147,125 +9134,83 @@
               </a:defRPr>
             </a:pPr>
             <a:r>
-              <a:t>Key Takeaway:</a:t>
-            </a:r>
-          </a:p>
-          <a:p>
-            <a:pPr>
-              <a:defRPr sz="600"/>
-            </a:pPr>
-          </a:p>
-          <a:p>
-            <a:pPr>
-              <a:defRPr sz="1200">
+              <a:t>Multigroup CFA &amp; Invariance Testing</a:t>
+            </a:r>
+          </a:p>
+          <a:p>
+            <a:pPr>
+              <a:defRPr sz="1100">
                 <a:solidFill>
                   <a:srgbClr val="323232"/>
                 </a:solidFill>
               </a:defRPr>
             </a:pPr>
             <a:r>
-              <a:t>The optimal factor structure of the UWES-9 remains unresolved.</a:t>
-            </a:r>
-          </a:p>
-          <a:p>
-            <a:pPr>
-              <a:defRPr sz="1200">
+              <a:t>Future research should use Multigroup CFA to determine if the factor structure is invariant across:</a:t>
+            </a:r>
+          </a:p>
+          <a:p>
+            <a:pPr>
+              <a:defRPr sz="400">
                 <a:solidFill>
                   <a:srgbClr val="323232"/>
                 </a:solidFill>
               </a:defRPr>
             </a:pPr>
-            <a:r>
-              <a:t>Further research is needed to understand how gender, nationality,</a:t>
-            </a:r>
-          </a:p>
-          <a:p>
-            <a:pPr>
-              <a:defRPr sz="1200">
+          </a:p>
+          <a:p>
+            <a:pPr>
+              <a:defRPr sz="1100">
                 <a:solidFill>
                   <a:srgbClr val="323232"/>
                 </a:solidFill>
               </a:defRPr>
             </a:pPr>
             <a:r>
-              <a:t>and occupation influence the measurement of work engagement.</a:t>
-            </a:r>
-          </a:p>
-          <a:p>
-            <a:pPr>
-              <a:defRPr sz="600"/>
-            </a:pPr>
-          </a:p>
-          <a:p>
-            <a:pPr>
-              <a:defRPr sz="1500" b="1">
-                <a:solidFill>
-                  <a:srgbClr val="E76F51"/>
-                </a:solidFill>
-              </a:defRPr>
-            </a:pPr>
-            <a:r>
-              <a:t>Future Directions:</a:t>
-            </a:r>
-          </a:p>
-          <a:p>
-            <a:pPr>
-              <a:defRPr sz="600"/>
-            </a:pPr>
-          </a:p>
-          <a:p>
-            <a:pPr>
-              <a:defRPr sz="1200">
+              <a:t>- Gender: Compare all-female vs. mixed-gender samples</a:t>
+            </a:r>
+          </a:p>
+          <a:p>
+            <a:pPr>
+              <a:defRPr sz="1100">
                 <a:solidFill>
                   <a:srgbClr val="323232"/>
                 </a:solidFill>
               </a:defRPr>
             </a:pPr>
             <a:r>
-              <a:t>- Test UWES-9 in larger all-female samples across different cultures</a:t>
-            </a:r>
-          </a:p>
-          <a:p>
-            <a:pPr>
-              <a:defRPr sz="1200">
+              <a:t>- Nationality: Test across Swedish, Norwegian, Finnish populations</a:t>
+            </a:r>
+          </a:p>
+          <a:p>
+            <a:pPr>
+              <a:defRPr sz="1100">
                 <a:solidFill>
                   <a:srgbClr val="323232"/>
                 </a:solidFill>
               </a:defRPr>
             </a:pPr>
             <a:r>
-              <a:t>- Develop gender-specific engagement instruments</a:t>
-            </a:r>
-          </a:p>
-          <a:p>
-            <a:pPr>
-              <a:defRPr sz="1200">
+              <a:t>- Occupation: Compare engagement structure across professions</a:t>
+            </a:r>
+          </a:p>
+          <a:p>
+            <a:pPr>
+              <a:defRPr sz="1100">
                 <a:solidFill>
                   <a:srgbClr val="323232"/>
                 </a:solidFill>
               </a:defRPr>
             </a:pPr>
             <a:r>
-              <a:t>- Investigate whether a shorter version (UWES-3) performs better</a:t>
-            </a:r>
-          </a:p>
-          <a:p>
-            <a:pPr>
-              <a:defRPr sz="1200">
-                <a:solidFill>
-                  <a:srgbClr val="323232"/>
-                </a:solidFill>
-              </a:defRPr>
-            </a:pPr>
-            <a:r>
-              <a:t>- Examine the role of occupation type in factor structure</a:t>
-            </a:r>
-          </a:p>
-        </p:txBody>
-      </p:sp>
-      <p:sp>
-        <p:nvSpPr>
-          <p:cNvPr id="5" name="TextBox 4"/>
+              <a:t>- This would reveal whether poor fit is due to instrument or sample</a:t>
+            </a:r>
+          </a:p>
+        </p:txBody>
+      </p:sp>
+      <p:sp>
+        <p:nvSpPr>
+          <p:cNvPr id="6" name="TextBox 5"/>
           <p:cNvSpPr txBox="1"/>
           <p:nvPr/>
         </p:nvSpPr>
@@ -8371,19 +9316,7 @@
               </a:defRPr>
             </a:pPr>
             <a:r>
-              <a:t>Factor Analysis Methods Applied</a:t>
-            </a:r>
-          </a:p>
-          <a:p>
-            <a:pPr algn="l">
-              <a:defRPr sz="1300">
-                <a:solidFill>
-                  <a:srgbClr val="E9C46A"/>
-                </a:solidFill>
-              </a:defRPr>
-            </a:pPr>
-            <a:r>
-              <a:t>EFA &amp; CFA Techniques Used in This Study</a:t>
+              <a:t>Conclusion</a:t>
             </a:r>
           </a:p>
         </p:txBody>
@@ -8431,574 +9364,227 @@
           </a:p>
         </p:txBody>
       </p:sp>
-      <p:graphicFrame>
-        <p:nvGraphicFramePr>
-          <p:cNvPr id="4" name="Table 3"/>
-          <p:cNvGraphicFramePr>
-            <a:graphicFrameLocks noGrp="1"/>
-          </p:cNvGraphicFramePr>
+      <p:sp>
+        <p:nvSpPr>
+          <p:cNvPr id="4" name="TextBox 3"/>
+          <p:cNvSpPr txBox="1"/>
           <p:nvPr/>
-        </p:nvGraphicFramePr>
-        <p:xfrm>
-          <a:off x="274320" y="1371600"/>
-          <a:ext cx="8595360" cy="4572000"/>
-        </p:xfrm>
-        <a:graphic>
-          <a:graphicData uri="http://schemas.openxmlformats.org/drawingml/2006/table">
-            <a:tbl>
-              <a:tblPr firstRow="1" bandRow="1">
-                <a:tableStyleId>{5C22544A-7EE6-4342-B048-85BDC9FD1C3A}</a:tableStyleId>
-              </a:tblPr>
-              <a:tblGrid>
-                <a:gridCol w="2286000"/>
-                <a:gridCol w="2743200"/>
-                <a:gridCol w="3566160"/>
-              </a:tblGrid>
-              <a:tr h="415636">
-                <a:tc>
-                  <a:txBody>
-                    <a:bodyPr/>
-                    <a:lstStyle/>
-                    <a:p>
-                      <a:pPr algn="ctr">
-                        <a:defRPr sz="1000" b="1">
-                          <a:solidFill>
-                            <a:srgbClr val="FFFFFF"/>
-                          </a:solidFill>
-                        </a:defRPr>
-                      </a:pPr>
-                      <a:r>
-                        <a:t>Method</a:t>
-                      </a:r>
-                    </a:p>
-                  </a:txBody>
-                  <a:tcPr anchor="ctr">
-                    <a:solidFill>
-                      <a:srgbClr val="6B2D7B"/>
-                    </a:solidFill>
-                  </a:tcPr>
-                </a:tc>
-                <a:tc>
-                  <a:txBody>
-                    <a:bodyPr/>
-                    <a:lstStyle/>
-                    <a:p>
-                      <a:pPr algn="ctr">
-                        <a:defRPr sz="1000" b="1">
-                          <a:solidFill>
-                            <a:srgbClr val="FFFFFF"/>
-                          </a:solidFill>
-                        </a:defRPr>
-                      </a:pPr>
-                      <a:r>
-                        <a:t>Purpose</a:t>
-                      </a:r>
-                    </a:p>
-                  </a:txBody>
-                  <a:tcPr anchor="ctr">
-                    <a:solidFill>
-                      <a:srgbClr val="6B2D7B"/>
-                    </a:solidFill>
-                  </a:tcPr>
-                </a:tc>
-                <a:tc>
-                  <a:txBody>
-                    <a:bodyPr/>
-                    <a:lstStyle/>
-                    <a:p>
-                      <a:pPr algn="ctr">
-                        <a:defRPr sz="1000" b="1">
-                          <a:solidFill>
-                            <a:srgbClr val="FFFFFF"/>
-                          </a:solidFill>
-                        </a:defRPr>
-                      </a:pPr>
-                      <a:r>
-                        <a:t>Key Finding</a:t>
-                      </a:r>
-                    </a:p>
-                  </a:txBody>
-                  <a:tcPr anchor="ctr">
-                    <a:solidFill>
-                      <a:srgbClr val="6B2D7B"/>
-                    </a:solidFill>
-                  </a:tcPr>
-                </a:tc>
-              </a:tr>
-              <a:tr h="415636">
-                <a:tc>
-                  <a:txBody>
-                    <a:bodyPr/>
-                    <a:lstStyle/>
-                    <a:p>
-                      <a:pPr algn="ctr">
-                        <a:defRPr sz="1000"/>
-                      </a:pPr>
-                      <a:r>
-                        <a:t>KMO Test</a:t>
-                      </a:r>
-                    </a:p>
-                  </a:txBody>
-                  <a:tcPr anchor="ctr"/>
-                </a:tc>
-                <a:tc>
-                  <a:txBody>
-                    <a:bodyPr/>
-                    <a:lstStyle/>
-                    <a:p>
-                      <a:pPr algn="ctr">
-                        <a:defRPr sz="1000"/>
-                      </a:pPr>
-                      <a:r>
-                        <a:t>Sampling adequacy</a:t>
-                      </a:r>
-                    </a:p>
-                  </a:txBody>
-                  <a:tcPr anchor="ctr"/>
-                </a:tc>
-                <a:tc>
-                  <a:txBody>
-                    <a:bodyPr/>
-                    <a:lstStyle/>
-                    <a:p>
-                      <a:pPr algn="ctr">
-                        <a:defRPr sz="1000"/>
-                      </a:pPr>
-                      <a:r>
-                        <a:t>0.922 (Marvellous)</a:t>
-                      </a:r>
-                    </a:p>
-                  </a:txBody>
-                  <a:tcPr anchor="ctr"/>
-                </a:tc>
-              </a:tr>
-              <a:tr h="415636">
-                <a:tc>
-                  <a:txBody>
-                    <a:bodyPr/>
-                    <a:lstStyle/>
-                    <a:p>
-                      <a:pPr algn="ctr">
-                        <a:defRPr sz="1000"/>
-                      </a:pPr>
-                      <a:r>
-                        <a:t>Bartlett's Test</a:t>
-                      </a:r>
-                    </a:p>
-                  </a:txBody>
-                  <a:tcPr anchor="ctr"/>
-                </a:tc>
-                <a:tc>
-                  <a:txBody>
-                    <a:bodyPr/>
-                    <a:lstStyle/>
-                    <a:p>
-                      <a:pPr algn="ctr">
-                        <a:defRPr sz="1000"/>
-                      </a:pPr>
-                      <a:r>
-                        <a:t>Sphericity</a:t>
-                      </a:r>
-                    </a:p>
-                  </a:txBody>
-                  <a:tcPr anchor="ctr"/>
-                </a:tc>
-                <a:tc>
-                  <a:txBody>
-                    <a:bodyPr/>
-                    <a:lstStyle/>
-                    <a:p>
-                      <a:pPr algn="ctr">
-                        <a:defRPr sz="1000"/>
-                      </a:pPr>
-                      <a:r>
-                        <a:t>p &lt; 0.001 (Significant)</a:t>
-                      </a:r>
-                    </a:p>
-                  </a:txBody>
-                  <a:tcPr anchor="ctr"/>
-                </a:tc>
-              </a:tr>
-              <a:tr h="415636">
-                <a:tc>
-                  <a:txBody>
-                    <a:bodyPr/>
-                    <a:lstStyle/>
-                    <a:p>
-                      <a:pPr algn="ctr">
-                        <a:defRPr sz="1000"/>
-                      </a:pPr>
-                      <a:r>
-                        <a:t>EFA (ML extraction)</a:t>
-                      </a:r>
-                    </a:p>
-                  </a:txBody>
-                  <a:tcPr anchor="ctr"/>
-                </a:tc>
-                <a:tc>
-                  <a:txBody>
-                    <a:bodyPr/>
-                    <a:lstStyle/>
-                    <a:p>
-                      <a:pPr algn="ctr">
-                        <a:defRPr sz="1000"/>
-                      </a:pPr>
-                      <a:r>
-                        <a:t>Identify factor structure</a:t>
-                      </a:r>
-                    </a:p>
-                  </a:txBody>
-                  <a:tcPr anchor="ctr"/>
-                </a:tc>
-                <a:tc>
-                  <a:txBody>
-                    <a:bodyPr/>
-                    <a:lstStyle/>
-                    <a:p>
-                      <a:pPr algn="ctr">
-                        <a:defRPr sz="1000"/>
-                      </a:pPr>
-                      <a:r>
-                        <a:t>1 factor, &gt; 70% variance</a:t>
-                      </a:r>
-                    </a:p>
-                  </a:txBody>
-                  <a:tcPr anchor="ctr"/>
-                </a:tc>
-              </a:tr>
-              <a:tr h="415636">
-                <a:tc>
-                  <a:txBody>
-                    <a:bodyPr/>
-                    <a:lstStyle/>
-                    <a:p>
-                      <a:pPr algn="ctr">
-                        <a:defRPr sz="1000"/>
-                      </a:pPr>
-                      <a:r>
-                        <a:t>Scree Plot</a:t>
-                      </a:r>
-                    </a:p>
-                  </a:txBody>
-                  <a:tcPr anchor="ctr"/>
-                </a:tc>
-                <a:tc>
-                  <a:txBody>
-                    <a:bodyPr/>
-                    <a:lstStyle/>
-                    <a:p>
-                      <a:pPr algn="ctr">
-                        <a:defRPr sz="1000"/>
-                      </a:pPr>
-                      <a:r>
-                        <a:t>Visual eigenvalue analysis</a:t>
-                      </a:r>
-                    </a:p>
-                  </a:txBody>
-                  <a:tcPr anchor="ctr"/>
-                </a:tc>
-                <a:tc>
-                  <a:txBody>
-                    <a:bodyPr/>
-                    <a:lstStyle/>
-                    <a:p>
-                      <a:pPr algn="ctr">
-                        <a:defRPr sz="1000"/>
-                      </a:pPr>
-                      <a:r>
-                        <a:t>Supports 1-factor</a:t>
-                      </a:r>
-                    </a:p>
-                  </a:txBody>
-                  <a:tcPr anchor="ctr"/>
-                </a:tc>
-              </a:tr>
-              <a:tr h="415636">
-                <a:tc>
-                  <a:txBody>
-                    <a:bodyPr/>
-                    <a:lstStyle/>
-                    <a:p>
-                      <a:pPr algn="ctr">
-                        <a:defRPr sz="1000"/>
-                      </a:pPr>
-                      <a:r>
-                        <a:t>Velicer's MAP</a:t>
-                      </a:r>
-                    </a:p>
-                  </a:txBody>
-                  <a:tcPr anchor="ctr"/>
-                </a:tc>
-                <a:tc>
-                  <a:txBody>
-                    <a:bodyPr/>
-                    <a:lstStyle/>
-                    <a:p>
-                      <a:pPr algn="ctr">
-                        <a:defRPr sz="1000"/>
-                      </a:pPr>
-                      <a:r>
-                        <a:t>Minimum average partial</a:t>
-                      </a:r>
-                    </a:p>
-                  </a:txBody>
-                  <a:tcPr anchor="ctr"/>
-                </a:tc>
-                <a:tc>
-                  <a:txBody>
-                    <a:bodyPr/>
-                    <a:lstStyle/>
-                    <a:p>
-                      <a:pPr algn="ctr">
-                        <a:defRPr sz="1000"/>
-                      </a:pPr>
-                      <a:r>
-                        <a:t>Supports 1-factor</a:t>
-                      </a:r>
-                    </a:p>
-                  </a:txBody>
-                  <a:tcPr anchor="ctr"/>
-                </a:tc>
-              </a:tr>
-              <a:tr h="415636">
-                <a:tc>
-                  <a:txBody>
-                    <a:bodyPr/>
-                    <a:lstStyle/>
-                    <a:p>
-                      <a:pPr algn="ctr">
-                        <a:defRPr sz="1000"/>
-                      </a:pPr>
-                      <a:r>
-                        <a:t>Parallel Analysis</a:t>
-                      </a:r>
-                    </a:p>
-                  </a:txBody>
-                  <a:tcPr anchor="ctr"/>
-                </a:tc>
-                <a:tc>
-                  <a:txBody>
-                    <a:bodyPr/>
-                    <a:lstStyle/>
-                    <a:p>
-                      <a:pPr algn="ctr">
-                        <a:defRPr sz="1000"/>
-                      </a:pPr>
-                      <a:r>
-                        <a:t>Compare with random data</a:t>
-                      </a:r>
-                    </a:p>
-                  </a:txBody>
-                  <a:tcPr anchor="ctr"/>
-                </a:tc>
-                <a:tc>
-                  <a:txBody>
-                    <a:bodyPr/>
-                    <a:lstStyle/>
-                    <a:p>
-                      <a:pPr algn="ctr">
-                        <a:defRPr sz="1000"/>
-                      </a:pPr>
-                      <a:r>
-                        <a:t>Suggested 4 factors</a:t>
-                      </a:r>
-                    </a:p>
-                  </a:txBody>
-                  <a:tcPr anchor="ctr"/>
-                </a:tc>
-              </a:tr>
-              <a:tr h="415636">
-                <a:tc>
-                  <a:txBody>
-                    <a:bodyPr/>
-                    <a:lstStyle/>
-                    <a:p>
-                      <a:pPr algn="ctr">
-                        <a:defRPr sz="1000"/>
-                      </a:pPr>
-                      <a:r>
-                        <a:t>CFA: 1-Factor</a:t>
-                      </a:r>
-                    </a:p>
-                  </a:txBody>
-                  <a:tcPr anchor="ctr"/>
-                </a:tc>
-                <a:tc>
-                  <a:txBody>
-                    <a:bodyPr/>
-                    <a:lstStyle/>
-                    <a:p>
-                      <a:pPr algn="ctr">
-                        <a:defRPr sz="1000"/>
-                      </a:pPr>
-                      <a:r>
-                        <a:t>Test unidimensional model</a:t>
-                      </a:r>
-                    </a:p>
-                  </a:txBody>
-                  <a:tcPr anchor="ctr"/>
-                </a:tc>
-                <a:tc>
-                  <a:txBody>
-                    <a:bodyPr/>
-                    <a:lstStyle/>
-                    <a:p>
-                      <a:pPr algn="ctr">
-                        <a:defRPr sz="1000"/>
-                      </a:pPr>
-                      <a:r>
-                        <a:t>RMSEA = 0.181 (poor)</a:t>
-                      </a:r>
-                    </a:p>
-                  </a:txBody>
-                  <a:tcPr anchor="ctr"/>
-                </a:tc>
-              </a:tr>
-              <a:tr h="415636">
-                <a:tc>
-                  <a:txBody>
-                    <a:bodyPr/>
-                    <a:lstStyle/>
-                    <a:p>
-                      <a:pPr algn="ctr">
-                        <a:defRPr sz="1000"/>
-                      </a:pPr>
-                      <a:r>
-                        <a:t>CFA: 2-Factor</a:t>
-                      </a:r>
-                    </a:p>
-                  </a:txBody>
-                  <a:tcPr anchor="ctr"/>
-                </a:tc>
-                <a:tc>
-                  <a:txBody>
-                    <a:bodyPr/>
-                    <a:lstStyle/>
-                    <a:p>
-                      <a:pPr algn="ctr">
-                        <a:defRPr sz="1000"/>
-                      </a:pPr>
-                      <a:r>
-                        <a:t>Test V+D / A split</a:t>
-                      </a:r>
-                    </a:p>
-                  </a:txBody>
-                  <a:tcPr anchor="ctr"/>
-                </a:tc>
-                <a:tc>
-                  <a:txBody>
-                    <a:bodyPr/>
-                    <a:lstStyle/>
-                    <a:p>
-                      <a:pPr algn="ctr">
-                        <a:defRPr sz="1000"/>
-                      </a:pPr>
-                      <a:r>
-                        <a:t>RMSEA = 0.192 (poor)</a:t>
-                      </a:r>
-                    </a:p>
-                  </a:txBody>
-                  <a:tcPr anchor="ctr"/>
-                </a:tc>
-              </a:tr>
-              <a:tr h="415636">
-                <a:tc>
-                  <a:txBody>
-                    <a:bodyPr/>
-                    <a:lstStyle/>
-                    <a:p>
-                      <a:pPr algn="ctr">
-                        <a:defRPr sz="1000"/>
-                      </a:pPr>
-                      <a:r>
-                        <a:t>CFA: 3-Factor</a:t>
-                      </a:r>
-                    </a:p>
-                  </a:txBody>
-                  <a:tcPr anchor="ctr"/>
-                </a:tc>
-                <a:tc>
-                  <a:txBody>
-                    <a:bodyPr/>
-                    <a:lstStyle/>
-                    <a:p>
-                      <a:pPr algn="ctr">
-                        <a:defRPr sz="1000"/>
-                      </a:pPr>
-                      <a:r>
-                        <a:t>Test V / D / A structure</a:t>
-                      </a:r>
-                    </a:p>
-                  </a:txBody>
-                  <a:tcPr anchor="ctr"/>
-                </a:tc>
-                <a:tc>
-                  <a:txBody>
-                    <a:bodyPr/>
-                    <a:lstStyle/>
-                    <a:p>
-                      <a:pPr algn="ctr">
-                        <a:defRPr sz="1000"/>
-                      </a:pPr>
-                      <a:r>
-                        <a:t>RMSEA = 0.167 (poor)</a:t>
-                      </a:r>
-                    </a:p>
-                  </a:txBody>
-                  <a:tcPr anchor="ctr"/>
-                </a:tc>
-              </a:tr>
-              <a:tr h="415640">
-                <a:tc>
-                  <a:txBody>
-                    <a:bodyPr/>
-                    <a:lstStyle/>
-                    <a:p>
-                      <a:pPr algn="ctr">
-                        <a:defRPr sz="1000"/>
-                      </a:pPr>
-                      <a:r>
-                        <a:t>Cronbach's Alpha</a:t>
-                      </a:r>
-                    </a:p>
-                  </a:txBody>
-                  <a:tcPr anchor="ctr"/>
-                </a:tc>
-                <a:tc>
-                  <a:txBody>
-                    <a:bodyPr/>
-                    <a:lstStyle/>
-                    <a:p>
-                      <a:pPr algn="ctr">
-                        <a:defRPr sz="1000"/>
-                      </a:pPr>
-                      <a:r>
-                        <a:t>Internal consistency</a:t>
-                      </a:r>
-                    </a:p>
-                  </a:txBody>
-                  <a:tcPr anchor="ctr"/>
-                </a:tc>
-                <a:tc>
-                  <a:txBody>
-                    <a:bodyPr/>
-                    <a:lstStyle/>
-                    <a:p>
-                      <a:pPr algn="ctr">
-                        <a:defRPr sz="1000"/>
-                      </a:pPr>
-                      <a:r>
-                        <a:t>0.947 (Excellent)</a:t>
-                      </a:r>
-                    </a:p>
-                  </a:txBody>
-                  <a:tcPr anchor="ctr"/>
-                </a:tc>
-              </a:tr>
-            </a:tbl>
-          </a:graphicData>
-        </a:graphic>
-      </p:graphicFrame>
+        </p:nvSpPr>
+        <p:spPr>
+          <a:xfrm>
+            <a:off x="457200" y="1371600"/>
+            <a:ext cx="8229600" cy="5029200"/>
+          </a:xfrm>
+          <a:prstGeom prst="rect">
+            <a:avLst/>
+          </a:prstGeom>
+          <a:noFill/>
+        </p:spPr>
+        <p:txBody>
+          <a:bodyPr wrap="square">
+            <a:spAutoFit/>
+          </a:bodyPr>
+          <a:lstStyle/>
+          <a:p>
+            <a:pPr>
+              <a:defRPr sz="1500" b="1">
+                <a:solidFill>
+                  <a:srgbClr val="6B2D7B"/>
+                </a:solidFill>
+              </a:defRPr>
+            </a:pPr>
+            <a:r>
+              <a:t>Study Summary:</a:t>
+            </a:r>
+          </a:p>
+          <a:p>
+            <a:pPr>
+              <a:defRPr sz="600"/>
+            </a:pPr>
+          </a:p>
+          <a:p>
+            <a:pPr>
+              <a:defRPr sz="1200">
+                <a:solidFill>
+                  <a:srgbClr val="323232"/>
+                </a:solidFill>
+              </a:defRPr>
+            </a:pPr>
+            <a:r>
+              <a:t>- EFA on n = 341 women: One-factor solution best fits the data</a:t>
+            </a:r>
+          </a:p>
+          <a:p>
+            <a:pPr>
+              <a:defRPr sz="1200">
+                <a:solidFill>
+                  <a:srgbClr val="323232"/>
+                </a:solidFill>
+              </a:defRPr>
+            </a:pPr>
+            <a:r>
+              <a:t>  (KMO = 0.922, &gt; 70% variance explained, all loadings 0.65-0.93)</a:t>
+            </a:r>
+          </a:p>
+          <a:p>
+            <a:pPr>
+              <a:defRPr sz="600"/>
+            </a:pPr>
+          </a:p>
+          <a:p>
+            <a:pPr>
+              <a:defRPr sz="1200">
+                <a:solidFill>
+                  <a:srgbClr val="323232"/>
+                </a:solidFill>
+              </a:defRPr>
+            </a:pPr>
+            <a:r>
+              <a:t>- CFA on n = 342 women: Could NOT confirm any model (1-, 2-, or 3-factor)</a:t>
+            </a:r>
+          </a:p>
+          <a:p>
+            <a:pPr>
+              <a:defRPr sz="1200">
+                <a:solidFill>
+                  <a:srgbClr val="323232"/>
+                </a:solidFill>
+              </a:defRPr>
+            </a:pPr>
+            <a:r>
+              <a:t>  (RMSEA never below 0.167, CFI/TLI below 0.95 for all models)</a:t>
+            </a:r>
+          </a:p>
+          <a:p>
+            <a:pPr>
+              <a:defRPr sz="600"/>
+            </a:pPr>
+          </a:p>
+          <a:p>
+            <a:pPr>
+              <a:defRPr sz="1500" b="1">
+                <a:solidFill>
+                  <a:srgbClr val="2A9D8F"/>
+                </a:solidFill>
+              </a:defRPr>
+            </a:pPr>
+            <a:r>
+              <a:t>Key Takeaway:</a:t>
+            </a:r>
+          </a:p>
+          <a:p>
+            <a:pPr>
+              <a:defRPr sz="600"/>
+            </a:pPr>
+          </a:p>
+          <a:p>
+            <a:pPr>
+              <a:defRPr sz="1200">
+                <a:solidFill>
+                  <a:srgbClr val="323232"/>
+                </a:solidFill>
+              </a:defRPr>
+            </a:pPr>
+            <a:r>
+              <a:t>The optimal factor structure of the UWES-9 remains unresolved.</a:t>
+            </a:r>
+          </a:p>
+          <a:p>
+            <a:pPr>
+              <a:defRPr sz="1200">
+                <a:solidFill>
+                  <a:srgbClr val="323232"/>
+                </a:solidFill>
+              </a:defRPr>
+            </a:pPr>
+            <a:r>
+              <a:t>Further research is needed to understand how gender, nationality,</a:t>
+            </a:r>
+          </a:p>
+          <a:p>
+            <a:pPr>
+              <a:defRPr sz="1200">
+                <a:solidFill>
+                  <a:srgbClr val="323232"/>
+                </a:solidFill>
+              </a:defRPr>
+            </a:pPr>
+            <a:r>
+              <a:t>and occupation influence the measurement of work engagement.</a:t>
+            </a:r>
+          </a:p>
+          <a:p>
+            <a:pPr>
+              <a:defRPr sz="600"/>
+            </a:pPr>
+          </a:p>
+          <a:p>
+            <a:pPr>
+              <a:defRPr sz="1500" b="1">
+                <a:solidFill>
+                  <a:srgbClr val="E76F51"/>
+                </a:solidFill>
+              </a:defRPr>
+            </a:pPr>
+            <a:r>
+              <a:t>Future Directions:</a:t>
+            </a:r>
+          </a:p>
+          <a:p>
+            <a:pPr>
+              <a:defRPr sz="600"/>
+            </a:pPr>
+          </a:p>
+          <a:p>
+            <a:pPr>
+              <a:defRPr sz="1200">
+                <a:solidFill>
+                  <a:srgbClr val="323232"/>
+                </a:solidFill>
+              </a:defRPr>
+            </a:pPr>
+            <a:r>
+              <a:t>- Test UWES-9 in larger all-female samples across different cultures</a:t>
+            </a:r>
+          </a:p>
+          <a:p>
+            <a:pPr>
+              <a:defRPr sz="1200">
+                <a:solidFill>
+                  <a:srgbClr val="323232"/>
+                </a:solidFill>
+              </a:defRPr>
+            </a:pPr>
+            <a:r>
+              <a:t>- Develop gender-specific engagement instruments</a:t>
+            </a:r>
+          </a:p>
+          <a:p>
+            <a:pPr>
+              <a:defRPr sz="1200">
+                <a:solidFill>
+                  <a:srgbClr val="323232"/>
+                </a:solidFill>
+              </a:defRPr>
+            </a:pPr>
+            <a:r>
+              <a:t>- Investigate whether a shorter version (UWES-3) performs better</a:t>
+            </a:r>
+          </a:p>
+          <a:p>
+            <a:pPr>
+              <a:defRPr sz="1200">
+                <a:solidFill>
+                  <a:srgbClr val="323232"/>
+                </a:solidFill>
+              </a:defRPr>
+            </a:pPr>
+            <a:r>
+              <a:t>- Examine the role of occupation type in factor structure</a:t>
+            </a:r>
+          </a:p>
+        </p:txBody>
+      </p:sp>
       <p:sp>
         <p:nvSpPr>
           <p:cNvPr id="5" name="TextBox 4"/>
@@ -9107,7 +9693,19 @@
               </a:defRPr>
             </a:pPr>
             <a:r>
-              <a:t>References</a:t>
+              <a:t>Factor Analysis Methods Applied</a:t>
+            </a:r>
+          </a:p>
+          <a:p>
+            <a:pPr algn="l">
+              <a:defRPr sz="1300">
+                <a:solidFill>
+                  <a:srgbClr val="E9C46A"/>
+                </a:solidFill>
+              </a:defRPr>
+            </a:pPr>
+            <a:r>
+              <a:t>EFA &amp; CFA Techniques Used in This Study</a:t>
             </a:r>
           </a:p>
         </p:txBody>
@@ -9155,6 +9753,730 @@
           </a:p>
         </p:txBody>
       </p:sp>
+      <p:graphicFrame>
+        <p:nvGraphicFramePr>
+          <p:cNvPr id="4" name="Table 3"/>
+          <p:cNvGraphicFramePr>
+            <a:graphicFrameLocks noGrp="1"/>
+          </p:cNvGraphicFramePr>
+          <p:nvPr/>
+        </p:nvGraphicFramePr>
+        <p:xfrm>
+          <a:off x="274320" y="1371600"/>
+          <a:ext cx="8595360" cy="4572000"/>
+        </p:xfrm>
+        <a:graphic>
+          <a:graphicData uri="http://schemas.openxmlformats.org/drawingml/2006/table">
+            <a:tbl>
+              <a:tblPr firstRow="1" bandRow="1">
+                <a:tableStyleId>{5C22544A-7EE6-4342-B048-85BDC9FD1C3A}</a:tableStyleId>
+              </a:tblPr>
+              <a:tblGrid>
+                <a:gridCol w="2286000"/>
+                <a:gridCol w="2743200"/>
+                <a:gridCol w="3566160"/>
+              </a:tblGrid>
+              <a:tr h="415636">
+                <a:tc>
+                  <a:txBody>
+                    <a:bodyPr/>
+                    <a:lstStyle/>
+                    <a:p>
+                      <a:pPr algn="ctr">
+                        <a:defRPr sz="1000" b="1">
+                          <a:solidFill>
+                            <a:srgbClr val="FFFFFF"/>
+                          </a:solidFill>
+                        </a:defRPr>
+                      </a:pPr>
+                      <a:r>
+                        <a:t>Method</a:t>
+                      </a:r>
+                    </a:p>
+                  </a:txBody>
+                  <a:tcPr anchor="ctr">
+                    <a:solidFill>
+                      <a:srgbClr val="6B2D7B"/>
+                    </a:solidFill>
+                  </a:tcPr>
+                </a:tc>
+                <a:tc>
+                  <a:txBody>
+                    <a:bodyPr/>
+                    <a:lstStyle/>
+                    <a:p>
+                      <a:pPr algn="ctr">
+                        <a:defRPr sz="1000" b="1">
+                          <a:solidFill>
+                            <a:srgbClr val="FFFFFF"/>
+                          </a:solidFill>
+                        </a:defRPr>
+                      </a:pPr>
+                      <a:r>
+                        <a:t>Purpose</a:t>
+                      </a:r>
+                    </a:p>
+                  </a:txBody>
+                  <a:tcPr anchor="ctr">
+                    <a:solidFill>
+                      <a:srgbClr val="6B2D7B"/>
+                    </a:solidFill>
+                  </a:tcPr>
+                </a:tc>
+                <a:tc>
+                  <a:txBody>
+                    <a:bodyPr/>
+                    <a:lstStyle/>
+                    <a:p>
+                      <a:pPr algn="ctr">
+                        <a:defRPr sz="1000" b="1">
+                          <a:solidFill>
+                            <a:srgbClr val="FFFFFF"/>
+                          </a:solidFill>
+                        </a:defRPr>
+                      </a:pPr>
+                      <a:r>
+                        <a:t>Key Finding</a:t>
+                      </a:r>
+                    </a:p>
+                  </a:txBody>
+                  <a:tcPr anchor="ctr">
+                    <a:solidFill>
+                      <a:srgbClr val="6B2D7B"/>
+                    </a:solidFill>
+                  </a:tcPr>
+                </a:tc>
+              </a:tr>
+              <a:tr h="415636">
+                <a:tc>
+                  <a:txBody>
+                    <a:bodyPr/>
+                    <a:lstStyle/>
+                    <a:p>
+                      <a:pPr algn="ctr">
+                        <a:defRPr sz="1000"/>
+                      </a:pPr>
+                      <a:r>
+                        <a:t>KMO Test</a:t>
+                      </a:r>
+                    </a:p>
+                  </a:txBody>
+                  <a:tcPr anchor="ctr"/>
+                </a:tc>
+                <a:tc>
+                  <a:txBody>
+                    <a:bodyPr/>
+                    <a:lstStyle/>
+                    <a:p>
+                      <a:pPr algn="ctr">
+                        <a:defRPr sz="1000"/>
+                      </a:pPr>
+                      <a:r>
+                        <a:t>Sampling adequacy</a:t>
+                      </a:r>
+                    </a:p>
+                  </a:txBody>
+                  <a:tcPr anchor="ctr"/>
+                </a:tc>
+                <a:tc>
+                  <a:txBody>
+                    <a:bodyPr/>
+                    <a:lstStyle/>
+                    <a:p>
+                      <a:pPr algn="ctr">
+                        <a:defRPr sz="1000"/>
+                      </a:pPr>
+                      <a:r>
+                        <a:t>0.922 (Marvellous)</a:t>
+                      </a:r>
+                    </a:p>
+                  </a:txBody>
+                  <a:tcPr anchor="ctr"/>
+                </a:tc>
+              </a:tr>
+              <a:tr h="415636">
+                <a:tc>
+                  <a:txBody>
+                    <a:bodyPr/>
+                    <a:lstStyle/>
+                    <a:p>
+                      <a:pPr algn="ctr">
+                        <a:defRPr sz="1000"/>
+                      </a:pPr>
+                      <a:r>
+                        <a:t>Bartlett's Test</a:t>
+                      </a:r>
+                    </a:p>
+                  </a:txBody>
+                  <a:tcPr anchor="ctr"/>
+                </a:tc>
+                <a:tc>
+                  <a:txBody>
+                    <a:bodyPr/>
+                    <a:lstStyle/>
+                    <a:p>
+                      <a:pPr algn="ctr">
+                        <a:defRPr sz="1000"/>
+                      </a:pPr>
+                      <a:r>
+                        <a:t>Sphericity</a:t>
+                      </a:r>
+                    </a:p>
+                  </a:txBody>
+                  <a:tcPr anchor="ctr"/>
+                </a:tc>
+                <a:tc>
+                  <a:txBody>
+                    <a:bodyPr/>
+                    <a:lstStyle/>
+                    <a:p>
+                      <a:pPr algn="ctr">
+                        <a:defRPr sz="1000"/>
+                      </a:pPr>
+                      <a:r>
+                        <a:t>p &lt; 0.001 (Significant)</a:t>
+                      </a:r>
+                    </a:p>
+                  </a:txBody>
+                  <a:tcPr anchor="ctr"/>
+                </a:tc>
+              </a:tr>
+              <a:tr h="415636">
+                <a:tc>
+                  <a:txBody>
+                    <a:bodyPr/>
+                    <a:lstStyle/>
+                    <a:p>
+                      <a:pPr algn="ctr">
+                        <a:defRPr sz="1000"/>
+                      </a:pPr>
+                      <a:r>
+                        <a:t>EFA (ML extraction)</a:t>
+                      </a:r>
+                    </a:p>
+                  </a:txBody>
+                  <a:tcPr anchor="ctr"/>
+                </a:tc>
+                <a:tc>
+                  <a:txBody>
+                    <a:bodyPr/>
+                    <a:lstStyle/>
+                    <a:p>
+                      <a:pPr algn="ctr">
+                        <a:defRPr sz="1000"/>
+                      </a:pPr>
+                      <a:r>
+                        <a:t>Identify factor structure</a:t>
+                      </a:r>
+                    </a:p>
+                  </a:txBody>
+                  <a:tcPr anchor="ctr"/>
+                </a:tc>
+                <a:tc>
+                  <a:txBody>
+                    <a:bodyPr/>
+                    <a:lstStyle/>
+                    <a:p>
+                      <a:pPr algn="ctr">
+                        <a:defRPr sz="1000"/>
+                      </a:pPr>
+                      <a:r>
+                        <a:t>1 factor, &gt; 70% variance</a:t>
+                      </a:r>
+                    </a:p>
+                  </a:txBody>
+                  <a:tcPr anchor="ctr"/>
+                </a:tc>
+              </a:tr>
+              <a:tr h="415636">
+                <a:tc>
+                  <a:txBody>
+                    <a:bodyPr/>
+                    <a:lstStyle/>
+                    <a:p>
+                      <a:pPr algn="ctr">
+                        <a:defRPr sz="1000"/>
+                      </a:pPr>
+                      <a:r>
+                        <a:t>Scree Plot</a:t>
+                      </a:r>
+                    </a:p>
+                  </a:txBody>
+                  <a:tcPr anchor="ctr"/>
+                </a:tc>
+                <a:tc>
+                  <a:txBody>
+                    <a:bodyPr/>
+                    <a:lstStyle/>
+                    <a:p>
+                      <a:pPr algn="ctr">
+                        <a:defRPr sz="1000"/>
+                      </a:pPr>
+                      <a:r>
+                        <a:t>Visual eigenvalue analysis</a:t>
+                      </a:r>
+                    </a:p>
+                  </a:txBody>
+                  <a:tcPr anchor="ctr"/>
+                </a:tc>
+                <a:tc>
+                  <a:txBody>
+                    <a:bodyPr/>
+                    <a:lstStyle/>
+                    <a:p>
+                      <a:pPr algn="ctr">
+                        <a:defRPr sz="1000"/>
+                      </a:pPr>
+                      <a:r>
+                        <a:t>Supports 1-factor</a:t>
+                      </a:r>
+                    </a:p>
+                  </a:txBody>
+                  <a:tcPr anchor="ctr"/>
+                </a:tc>
+              </a:tr>
+              <a:tr h="415636">
+                <a:tc>
+                  <a:txBody>
+                    <a:bodyPr/>
+                    <a:lstStyle/>
+                    <a:p>
+                      <a:pPr algn="ctr">
+                        <a:defRPr sz="1000"/>
+                      </a:pPr>
+                      <a:r>
+                        <a:t>Velicer's MAP</a:t>
+                      </a:r>
+                    </a:p>
+                  </a:txBody>
+                  <a:tcPr anchor="ctr"/>
+                </a:tc>
+                <a:tc>
+                  <a:txBody>
+                    <a:bodyPr/>
+                    <a:lstStyle/>
+                    <a:p>
+                      <a:pPr algn="ctr">
+                        <a:defRPr sz="1000"/>
+                      </a:pPr>
+                      <a:r>
+                        <a:t>Minimum average partial</a:t>
+                      </a:r>
+                    </a:p>
+                  </a:txBody>
+                  <a:tcPr anchor="ctr"/>
+                </a:tc>
+                <a:tc>
+                  <a:txBody>
+                    <a:bodyPr/>
+                    <a:lstStyle/>
+                    <a:p>
+                      <a:pPr algn="ctr">
+                        <a:defRPr sz="1000"/>
+                      </a:pPr>
+                      <a:r>
+                        <a:t>Supports 1-factor</a:t>
+                      </a:r>
+                    </a:p>
+                  </a:txBody>
+                  <a:tcPr anchor="ctr"/>
+                </a:tc>
+              </a:tr>
+              <a:tr h="415636">
+                <a:tc>
+                  <a:txBody>
+                    <a:bodyPr/>
+                    <a:lstStyle/>
+                    <a:p>
+                      <a:pPr algn="ctr">
+                        <a:defRPr sz="1000"/>
+                      </a:pPr>
+                      <a:r>
+                        <a:t>Parallel Analysis</a:t>
+                      </a:r>
+                    </a:p>
+                  </a:txBody>
+                  <a:tcPr anchor="ctr"/>
+                </a:tc>
+                <a:tc>
+                  <a:txBody>
+                    <a:bodyPr/>
+                    <a:lstStyle/>
+                    <a:p>
+                      <a:pPr algn="ctr">
+                        <a:defRPr sz="1000"/>
+                      </a:pPr>
+                      <a:r>
+                        <a:t>Compare with random data</a:t>
+                      </a:r>
+                    </a:p>
+                  </a:txBody>
+                  <a:tcPr anchor="ctr"/>
+                </a:tc>
+                <a:tc>
+                  <a:txBody>
+                    <a:bodyPr/>
+                    <a:lstStyle/>
+                    <a:p>
+                      <a:pPr algn="ctr">
+                        <a:defRPr sz="1000"/>
+                      </a:pPr>
+                      <a:r>
+                        <a:t>Suggested 4 factors</a:t>
+                      </a:r>
+                    </a:p>
+                  </a:txBody>
+                  <a:tcPr anchor="ctr"/>
+                </a:tc>
+              </a:tr>
+              <a:tr h="415636">
+                <a:tc>
+                  <a:txBody>
+                    <a:bodyPr/>
+                    <a:lstStyle/>
+                    <a:p>
+                      <a:pPr algn="ctr">
+                        <a:defRPr sz="1000"/>
+                      </a:pPr>
+                      <a:r>
+                        <a:t>CFA: 1-Factor</a:t>
+                      </a:r>
+                    </a:p>
+                  </a:txBody>
+                  <a:tcPr anchor="ctr"/>
+                </a:tc>
+                <a:tc>
+                  <a:txBody>
+                    <a:bodyPr/>
+                    <a:lstStyle/>
+                    <a:p>
+                      <a:pPr algn="ctr">
+                        <a:defRPr sz="1000"/>
+                      </a:pPr>
+                      <a:r>
+                        <a:t>Test unidimensional model</a:t>
+                      </a:r>
+                    </a:p>
+                  </a:txBody>
+                  <a:tcPr anchor="ctr"/>
+                </a:tc>
+                <a:tc>
+                  <a:txBody>
+                    <a:bodyPr/>
+                    <a:lstStyle/>
+                    <a:p>
+                      <a:pPr algn="ctr">
+                        <a:defRPr sz="1000"/>
+                      </a:pPr>
+                      <a:r>
+                        <a:t>RMSEA = 0.181 (poor)</a:t>
+                      </a:r>
+                    </a:p>
+                  </a:txBody>
+                  <a:tcPr anchor="ctr"/>
+                </a:tc>
+              </a:tr>
+              <a:tr h="415636">
+                <a:tc>
+                  <a:txBody>
+                    <a:bodyPr/>
+                    <a:lstStyle/>
+                    <a:p>
+                      <a:pPr algn="ctr">
+                        <a:defRPr sz="1000"/>
+                      </a:pPr>
+                      <a:r>
+                        <a:t>CFA: 2-Factor</a:t>
+                      </a:r>
+                    </a:p>
+                  </a:txBody>
+                  <a:tcPr anchor="ctr"/>
+                </a:tc>
+                <a:tc>
+                  <a:txBody>
+                    <a:bodyPr/>
+                    <a:lstStyle/>
+                    <a:p>
+                      <a:pPr algn="ctr">
+                        <a:defRPr sz="1000"/>
+                      </a:pPr>
+                      <a:r>
+                        <a:t>Test V+D / A split</a:t>
+                      </a:r>
+                    </a:p>
+                  </a:txBody>
+                  <a:tcPr anchor="ctr"/>
+                </a:tc>
+                <a:tc>
+                  <a:txBody>
+                    <a:bodyPr/>
+                    <a:lstStyle/>
+                    <a:p>
+                      <a:pPr algn="ctr">
+                        <a:defRPr sz="1000"/>
+                      </a:pPr>
+                      <a:r>
+                        <a:t>RMSEA = 0.192 (poor)</a:t>
+                      </a:r>
+                    </a:p>
+                  </a:txBody>
+                  <a:tcPr anchor="ctr"/>
+                </a:tc>
+              </a:tr>
+              <a:tr h="415636">
+                <a:tc>
+                  <a:txBody>
+                    <a:bodyPr/>
+                    <a:lstStyle/>
+                    <a:p>
+                      <a:pPr algn="ctr">
+                        <a:defRPr sz="1000"/>
+                      </a:pPr>
+                      <a:r>
+                        <a:t>CFA: 3-Factor</a:t>
+                      </a:r>
+                    </a:p>
+                  </a:txBody>
+                  <a:tcPr anchor="ctr"/>
+                </a:tc>
+                <a:tc>
+                  <a:txBody>
+                    <a:bodyPr/>
+                    <a:lstStyle/>
+                    <a:p>
+                      <a:pPr algn="ctr">
+                        <a:defRPr sz="1000"/>
+                      </a:pPr>
+                      <a:r>
+                        <a:t>Test V / D / A structure</a:t>
+                      </a:r>
+                    </a:p>
+                  </a:txBody>
+                  <a:tcPr anchor="ctr"/>
+                </a:tc>
+                <a:tc>
+                  <a:txBody>
+                    <a:bodyPr/>
+                    <a:lstStyle/>
+                    <a:p>
+                      <a:pPr algn="ctr">
+                        <a:defRPr sz="1000"/>
+                      </a:pPr>
+                      <a:r>
+                        <a:t>RMSEA = 0.167 (poor)</a:t>
+                      </a:r>
+                    </a:p>
+                  </a:txBody>
+                  <a:tcPr anchor="ctr"/>
+                </a:tc>
+              </a:tr>
+              <a:tr h="415640">
+                <a:tc>
+                  <a:txBody>
+                    <a:bodyPr/>
+                    <a:lstStyle/>
+                    <a:p>
+                      <a:pPr algn="ctr">
+                        <a:defRPr sz="1000"/>
+                      </a:pPr>
+                      <a:r>
+                        <a:t>Cronbach's Alpha</a:t>
+                      </a:r>
+                    </a:p>
+                  </a:txBody>
+                  <a:tcPr anchor="ctr"/>
+                </a:tc>
+                <a:tc>
+                  <a:txBody>
+                    <a:bodyPr/>
+                    <a:lstStyle/>
+                    <a:p>
+                      <a:pPr algn="ctr">
+                        <a:defRPr sz="1000"/>
+                      </a:pPr>
+                      <a:r>
+                        <a:t>Internal consistency</a:t>
+                      </a:r>
+                    </a:p>
+                  </a:txBody>
+                  <a:tcPr anchor="ctr"/>
+                </a:tc>
+                <a:tc>
+                  <a:txBody>
+                    <a:bodyPr/>
+                    <a:lstStyle/>
+                    <a:p>
+                      <a:pPr algn="ctr">
+                        <a:defRPr sz="1000"/>
+                      </a:pPr>
+                      <a:r>
+                        <a:t>0.947 (Excellent)</a:t>
+                      </a:r>
+                    </a:p>
+                  </a:txBody>
+                  <a:tcPr anchor="ctr"/>
+                </a:tc>
+              </a:tr>
+            </a:tbl>
+          </a:graphicData>
+        </a:graphic>
+      </p:graphicFrame>
+      <p:sp>
+        <p:nvSpPr>
+          <p:cNvPr id="5" name="TextBox 4"/>
+          <p:cNvSpPr txBox="1"/>
+          <p:nvPr/>
+        </p:nvSpPr>
+        <p:spPr>
+          <a:xfrm>
+            <a:off x="274320" y="6400800"/>
+            <a:ext cx="8595360" cy="365760"/>
+          </a:xfrm>
+          <a:prstGeom prst="rect">
+            <a:avLst/>
+          </a:prstGeom>
+          <a:noFill/>
+        </p:spPr>
+        <p:txBody>
+          <a:bodyPr wrap="none">
+            <a:spAutoFit/>
+          </a:bodyPr>
+          <a:lstStyle/>
+          <a:p>
+            <a:pPr algn="ctr">
+              <a:defRPr sz="800">
+                <a:solidFill>
+                  <a:srgbClr val="969696"/>
+                </a:solidFill>
+              </a:defRPr>
+            </a:pPr>
+            <a:r>
+              <a:t>Introduction | Literature Review | Methodology | Results | Discussion | Conclusion | References</a:t>
+            </a:r>
+          </a:p>
+        </p:txBody>
+      </p:sp>
+    </p:spTree>
+  </p:cSld>
+  <p:clrMapOvr>
+    <a:masterClrMapping/>
+  </p:clrMapOvr>
+</p:sld>
+</file>
+
+<file path=ppt/slides/slide25.xml><?xml version="1.0" encoding="utf-8"?>
+<p:sld xmlns:a="http://schemas.openxmlformats.org/drawingml/2006/main" xmlns:p="http://schemas.openxmlformats.org/presentationml/2006/main" xmlns:r="http://schemas.openxmlformats.org/officeDocument/2006/relationships">
+  <p:cSld>
+    <p:bg>
+      <p:bgPr>
+        <a:solidFill>
+          <a:srgbClr val="FAF7FC"/>
+        </a:solidFill>
+        <a:effectLst/>
+      </p:bgPr>
+    </p:bg>
+    <p:spTree>
+      <p:nvGrpSpPr>
+        <p:cNvPr id="1" name=""/>
+        <p:cNvGrpSpPr/>
+        <p:nvPr/>
+      </p:nvGrpSpPr>
+      <p:grpSpPr/>
+      <p:sp>
+        <p:nvSpPr>
+          <p:cNvPr id="2" name="Rectangle 1"/>
+          <p:cNvSpPr/>
+          <p:nvPr/>
+        </p:nvSpPr>
+        <p:spPr>
+          <a:xfrm>
+            <a:off x="0" y="0"/>
+            <a:ext cx="9144000" cy="1097280"/>
+          </a:xfrm>
+          <a:prstGeom prst="rect">
+            <a:avLst/>
+          </a:prstGeom>
+          <a:solidFill>
+            <a:srgbClr val="6B2D7B"/>
+          </a:solidFill>
+          <a:ln>
+            <a:noFill/>
+          </a:ln>
+        </p:spPr>
+        <p:style>
+          <a:lnRef idx="1">
+            <a:schemeClr val="accent1"/>
+          </a:lnRef>
+          <a:fillRef idx="3">
+            <a:schemeClr val="accent1"/>
+          </a:fillRef>
+          <a:effectRef idx="2">
+            <a:schemeClr val="accent1"/>
+          </a:effectRef>
+          <a:fontRef idx="minor">
+            <a:schemeClr val="lt1"/>
+          </a:fontRef>
+        </p:style>
+        <p:txBody>
+          <a:bodyPr rtlCol="0" anchor="ctr" wrap="square" lIns="457200" tIns="137160"/>
+          <a:lstStyle/>
+          <a:p>
+            <a:pPr algn="l">
+              <a:defRPr sz="2600" b="1">
+                <a:solidFill>
+                  <a:srgbClr val="FFFFFF"/>
+                </a:solidFill>
+              </a:defRPr>
+            </a:pPr>
+            <a:r>
+              <a:t>References</a:t>
+            </a:r>
+          </a:p>
+        </p:txBody>
+      </p:sp>
+      <p:sp>
+        <p:nvSpPr>
+          <p:cNvPr id="3" name="Rectangle 2"/>
+          <p:cNvSpPr/>
+          <p:nvPr/>
+        </p:nvSpPr>
+        <p:spPr>
+          <a:xfrm>
+            <a:off x="0" y="1097280"/>
+            <a:ext cx="9144000" cy="45720"/>
+          </a:xfrm>
+          <a:prstGeom prst="rect">
+            <a:avLst/>
+          </a:prstGeom>
+          <a:solidFill>
+            <a:srgbClr val="2A9D8F"/>
+          </a:solidFill>
+          <a:ln>
+            <a:noFill/>
+          </a:ln>
+        </p:spPr>
+        <p:style>
+          <a:lnRef idx="1">
+            <a:schemeClr val="accent1"/>
+          </a:lnRef>
+          <a:fillRef idx="3">
+            <a:schemeClr val="accent1"/>
+          </a:fillRef>
+          <a:effectRef idx="2">
+            <a:schemeClr val="accent1"/>
+          </a:effectRef>
+          <a:fontRef idx="minor">
+            <a:schemeClr val="lt1"/>
+          </a:fontRef>
+        </p:style>
+        <p:txBody>
+          <a:bodyPr rtlCol="0" anchor="ctr"/>
+          <a:lstStyle/>
+          <a:p>
+            <a:pPr algn="ctr"/>
+          </a:p>
+        </p:txBody>
+      </p:sp>
       <p:sp>
         <p:nvSpPr>
           <p:cNvPr id="4" name="TextBox 3"/>
@@ -9368,7 +10690,7 @@
 </p:sld>
 </file>
 
-<file path=ppt/slides/slide25.xml><?xml version="1.0" encoding="utf-8"?>
+<file path=ppt/slides/slide26.xml><?xml version="1.0" encoding="utf-8"?>
 <p:sld xmlns:a="http://schemas.openxmlformats.org/drawingml/2006/main" xmlns:p="http://schemas.openxmlformats.org/presentationml/2006/main" xmlns:r="http://schemas.openxmlformats.org/officeDocument/2006/relationships">
   <p:cSld>
     <p:bg>
@@ -10737,378 +12059,33 @@
           </a:p>
         </p:txBody>
       </p:sp>
-      <p:sp>
-        <p:nvSpPr>
-          <p:cNvPr id="4" name="TextBox 3"/>
-          <p:cNvSpPr txBox="1"/>
+      <p:pic>
+        <p:nvPicPr>
+          <p:cNvPr id="4" name="Picture 3" descr="split_sample_flowchart.png"/>
+          <p:cNvPicPr>
+            <a:picLocks noChangeAspect="1"/>
+          </p:cNvPicPr>
           <p:nvPr/>
-        </p:nvSpPr>
+        </p:nvPicPr>
+        <p:blipFill>
+          <a:blip r:embed="rId2"/>
+          <a:stretch>
+            <a:fillRect/>
+          </a:stretch>
+        </p:blipFill>
         <p:spPr>
           <a:xfrm>
-            <a:off x="274320" y="1371600"/>
-            <a:ext cx="4114800" cy="5029200"/>
+            <a:off x="182880" y="1188720"/>
+            <a:ext cx="8778240" cy="5303520"/>
           </a:xfrm>
           <a:prstGeom prst="rect">
             <a:avLst/>
           </a:prstGeom>
-          <a:noFill/>
         </p:spPr>
-        <p:txBody>
-          <a:bodyPr wrap="square">
-            <a:spAutoFit/>
-          </a:bodyPr>
-          <a:lstStyle/>
-          <a:p>
-            <a:pPr>
-              <a:defRPr sz="1400" b="1">
-                <a:solidFill>
-                  <a:srgbClr val="6B2D7B"/>
-                </a:solidFill>
-              </a:defRPr>
-            </a:pPr>
-            <a:r>
-              <a:t>Study Design:</a:t>
-            </a:r>
-          </a:p>
-          <a:p>
-            <a:pPr>
-              <a:defRPr sz="600"/>
-            </a:pPr>
-          </a:p>
-          <a:p>
-            <a:pPr>
-              <a:defRPr sz="1200">
-                <a:solidFill>
-                  <a:srgbClr val="323232"/>
-                </a:solidFill>
-              </a:defRPr>
-            </a:pPr>
-            <a:r>
-              <a:t>- Cross-sectional study (2015 data)</a:t>
-            </a:r>
-          </a:p>
-          <a:p>
-            <a:pPr>
-              <a:defRPr sz="1200">
-                <a:solidFill>
-                  <a:srgbClr val="323232"/>
-                </a:solidFill>
-              </a:defRPr>
-            </a:pPr>
-            <a:r>
-              <a:t>- Part of 20-year longitudinal follow-up</a:t>
-            </a:r>
-          </a:p>
-          <a:p>
-            <a:pPr>
-              <a:defRPr sz="1200">
-                <a:solidFill>
-                  <a:srgbClr val="323232"/>
-                </a:solidFill>
-              </a:defRPr>
-            </a:pPr>
-            <a:r>
-              <a:t>- Originally recruited as girls (1995)</a:t>
-            </a:r>
-          </a:p>
-          <a:p>
-            <a:pPr>
-              <a:defRPr sz="1200">
-                <a:solidFill>
-                  <a:srgbClr val="323232"/>
-                </a:solidFill>
-              </a:defRPr>
-            </a:pPr>
-            <a:r>
-              <a:t>- Currently working women only</a:t>
-            </a:r>
-          </a:p>
-          <a:p>
-            <a:pPr>
-              <a:defRPr sz="1200">
-                <a:solidFill>
-                  <a:srgbClr val="323232"/>
-                </a:solidFill>
-              </a:defRPr>
-            </a:pPr>
-            <a:r>
-              <a:t>- Final sample: n = 702</a:t>
-            </a:r>
-          </a:p>
-          <a:p>
-            <a:pPr>
-              <a:defRPr sz="600"/>
-            </a:pPr>
-          </a:p>
-          <a:p>
-            <a:pPr>
-              <a:defRPr sz="1400" b="1">
-                <a:solidFill>
-                  <a:srgbClr val="6B2D7B"/>
-                </a:solidFill>
-              </a:defRPr>
-            </a:pPr>
-            <a:r>
-              <a:t>Sample Split:</a:t>
-            </a:r>
-          </a:p>
-          <a:p>
-            <a:pPr>
-              <a:defRPr sz="600"/>
-            </a:pPr>
-          </a:p>
-          <a:p>
-            <a:pPr>
-              <a:defRPr sz="1200">
-                <a:solidFill>
-                  <a:srgbClr val="323232"/>
-                </a:solidFill>
-              </a:defRPr>
-            </a:pPr>
-            <a:r>
-              <a:t>- EFA sample: n = 341</a:t>
-            </a:r>
-          </a:p>
-          <a:p>
-            <a:pPr>
-              <a:defRPr sz="1200">
-                <a:solidFill>
-                  <a:srgbClr val="323232"/>
-                </a:solidFill>
-              </a:defRPr>
-            </a:pPr>
-            <a:r>
-              <a:t>- CFA sample: n = 342</a:t>
-            </a:r>
-          </a:p>
-          <a:p>
-            <a:pPr>
-              <a:defRPr sz="1200">
-                <a:solidFill>
-                  <a:srgbClr val="323232"/>
-                </a:solidFill>
-              </a:defRPr>
-            </a:pPr>
-            <a:r>
-              <a:t>- 19 cases excluded (missing data, 3%)</a:t>
-            </a:r>
-          </a:p>
-          <a:p>
-            <a:pPr>
-              <a:defRPr sz="1200">
-                <a:solidFill>
-                  <a:srgbClr val="323232"/>
-                </a:solidFill>
-              </a:defRPr>
-            </a:pPr>
-            <a:r>
-              <a:t>- Total with complete data: n = 683</a:t>
-            </a:r>
-          </a:p>
-        </p:txBody>
-      </p:sp>
+      </p:pic>
       <p:sp>
         <p:nvSpPr>
           <p:cNvPr id="5" name="TextBox 4"/>
-          <p:cNvSpPr txBox="1"/>
-          <p:nvPr/>
-        </p:nvSpPr>
-        <p:spPr>
-          <a:xfrm>
-            <a:off x="4572000" y="1371600"/>
-            <a:ext cx="4389120" cy="5029200"/>
-          </a:xfrm>
-          <a:prstGeom prst="rect">
-            <a:avLst/>
-          </a:prstGeom>
-          <a:noFill/>
-        </p:spPr>
-        <p:txBody>
-          <a:bodyPr wrap="square">
-            <a:spAutoFit/>
-          </a:bodyPr>
-          <a:lstStyle/>
-          <a:p>
-            <a:pPr>
-              <a:defRPr sz="1400" b="1">
-                <a:solidFill>
-                  <a:srgbClr val="2A9D8F"/>
-                </a:solidFill>
-              </a:defRPr>
-            </a:pPr>
-            <a:r>
-              <a:t>Statistical Methods:</a:t>
-            </a:r>
-          </a:p>
-          <a:p>
-            <a:pPr>
-              <a:defRPr sz="600"/>
-            </a:pPr>
-          </a:p>
-          <a:p>
-            <a:pPr>
-              <a:defRPr sz="1200">
-                <a:solidFill>
-                  <a:srgbClr val="323232"/>
-                </a:solidFill>
-              </a:defRPr>
-            </a:pPr>
-            <a:r>
-              <a:t>Exploratory Factor Analysis (EFA):</a:t>
-            </a:r>
-          </a:p>
-          <a:p>
-            <a:pPr>
-              <a:defRPr sz="1200">
-                <a:solidFill>
-                  <a:srgbClr val="323232"/>
-                </a:solidFill>
-              </a:defRPr>
-            </a:pPr>
-            <a:r>
-              <a:t>  - Maximum likelihood extraction</a:t>
-            </a:r>
-          </a:p>
-          <a:p>
-            <a:pPr>
-              <a:defRPr sz="1200">
-                <a:solidFill>
-                  <a:srgbClr val="323232"/>
-                </a:solidFill>
-              </a:defRPr>
-            </a:pPr>
-            <a:r>
-              <a:t>  - Eigenvalues &gt; 1 criterion</a:t>
-            </a:r>
-          </a:p>
-          <a:p>
-            <a:pPr>
-              <a:defRPr sz="1200">
-                <a:solidFill>
-                  <a:srgbClr val="323232"/>
-                </a:solidFill>
-              </a:defRPr>
-            </a:pPr>
-            <a:r>
-              <a:t>  - Promax rotation (forced 3-factor)</a:t>
-            </a:r>
-          </a:p>
-          <a:p>
-            <a:pPr>
-              <a:defRPr sz="1200">
-                <a:solidFill>
-                  <a:srgbClr val="323232"/>
-                </a:solidFill>
-              </a:defRPr>
-            </a:pPr>
-            <a:r>
-              <a:t>  - Parallel Analysis</a:t>
-            </a:r>
-          </a:p>
-          <a:p>
-            <a:pPr>
-              <a:defRPr sz="1200">
-                <a:solidFill>
-                  <a:srgbClr val="323232"/>
-                </a:solidFill>
-              </a:defRPr>
-            </a:pPr>
-            <a:r>
-              <a:t>  - Velicer's MAP test</a:t>
-            </a:r>
-          </a:p>
-          <a:p>
-            <a:pPr>
-              <a:defRPr sz="600"/>
-            </a:pPr>
-          </a:p>
-          <a:p>
-            <a:pPr>
-              <a:defRPr sz="1200">
-                <a:solidFill>
-                  <a:srgbClr val="323232"/>
-                </a:solidFill>
-              </a:defRPr>
-            </a:pPr>
-            <a:r>
-              <a:t>Confirmatory Factor Analysis (CFA):</a:t>
-            </a:r>
-          </a:p>
-          <a:p>
-            <a:pPr>
-              <a:defRPr sz="1200">
-                <a:solidFill>
-                  <a:srgbClr val="323232"/>
-                </a:solidFill>
-              </a:defRPr>
-            </a:pPr>
-            <a:r>
-              <a:t>  - Maximum likelihood estimation</a:t>
-            </a:r>
-          </a:p>
-          <a:p>
-            <a:pPr>
-              <a:defRPr sz="1200">
-                <a:solidFill>
-                  <a:srgbClr val="323232"/>
-                </a:solidFill>
-              </a:defRPr>
-            </a:pPr>
-            <a:r>
-              <a:t>  - Three models tested:</a:t>
-            </a:r>
-          </a:p>
-          <a:p>
-            <a:pPr>
-              <a:defRPr sz="1200">
-                <a:solidFill>
-                  <a:srgbClr val="323232"/>
-                </a:solidFill>
-              </a:defRPr>
-            </a:pPr>
-            <a:r>
-              <a:t>    1-factor, 2-factor, 3-factor</a:t>
-            </a:r>
-          </a:p>
-          <a:p>
-            <a:pPr>
-              <a:defRPr sz="600"/>
-            </a:pPr>
-          </a:p>
-          <a:p>
-            <a:pPr>
-              <a:defRPr sz="1200">
-                <a:solidFill>
-                  <a:srgbClr val="323232"/>
-                </a:solidFill>
-              </a:defRPr>
-            </a:pPr>
-            <a:r>
-              <a:t>Software: Stata 14 + SPSS</a:t>
-            </a:r>
-          </a:p>
-          <a:p>
-            <a:pPr>
-              <a:defRPr sz="600"/>
-            </a:pPr>
-          </a:p>
-          <a:p>
-            <a:pPr>
-              <a:defRPr sz="1000" b="0">
-                <a:solidFill>
-                  <a:srgbClr val="787878"/>
-                </a:solidFill>
-              </a:defRPr>
-            </a:pPr>
-            <a:r>
-              <a:t>Ethics: Uppsala Regional Board (2014/401)</a:t>
-            </a:r>
-          </a:p>
-        </p:txBody>
-      </p:sp>
-      <p:sp>
-        <p:nvSpPr>
-          <p:cNvPr id="6" name="TextBox 5"/>
           <p:cNvSpPr txBox="1"/>
           <p:nvPr/>
         </p:nvSpPr>

</xml_diff>